<commit_message>
Regenerate deck.pdf + deck.pptx + export template
</commit_message>
<xml_diff>
--- a/deck.pptx
+++ b/deck.pptx
@@ -3127,6 +3127,88 @@
           </a:prstGeom>
         </p:spPr>
       </p:pic>
+      <p:sp>
+        <p:nvSpPr>
+          <p:cNvPr id="3" name="TextBox 2"/>
+          <p:cNvSpPr txBox="1"/>
+          <p:nvPr/>
+        </p:nvSpPr>
+        <p:spPr>
+          <a:xfrm>
+            <a:off x="952476" y="2287877"/>
+            <a:ext cx="4094605" cy="1160086"/>
+          </a:xfrm>
+          <a:prstGeom prst="rect">
+            <a:avLst/>
+          </a:prstGeom>
+          <a:noFill/>
+        </p:spPr>
+        <p:txBody>
+          <a:bodyPr wrap="square" lIns="0" rIns="0" tIns="0" bIns="0" anchor="ctr">
+            <a:spAutoFit/>
+          </a:bodyPr>
+          <a:lstStyle/>
+          <a:p>
+            <a:pPr algn="l"/>
+            <a:r>
+              <a:rPr sz="3899" b="1" i="0">
+                <a:solidFill>
+                  <a:srgbClr val="FFFFFF"/>
+                </a:solidFill>
+                <a:latin typeface="Lato"/>
+              </a:rPr>
+              <a:t>Évaluer les risques professionnels</a:t>
+            </a:r>
+          </a:p>
+        </p:txBody>
+      </p:sp>
+      <p:sp>
+        <p:nvSpPr>
+          <p:cNvPr id="4" name="TextBox 3"/>
+          <p:cNvSpPr txBox="1"/>
+          <p:nvPr/>
+        </p:nvSpPr>
+        <p:spPr>
+          <a:xfrm>
+            <a:off x="952476" y="3636524"/>
+            <a:ext cx="4433032" cy="914377"/>
+          </a:xfrm>
+          <a:prstGeom prst="rect">
+            <a:avLst/>
+          </a:prstGeom>
+          <a:noFill/>
+        </p:spPr>
+        <p:txBody>
+          <a:bodyPr wrap="square" lIns="0" rIns="0" tIns="0" bIns="0" anchor="ctr">
+            <a:spAutoFit/>
+          </a:bodyPr>
+          <a:lstStyle/>
+          <a:p>
+            <a:pPr algn="l"/>
+            <a:r>
+              <a:rPr sz="1499" b="0" i="0">
+                <a:solidFill>
+                  <a:srgbClr val="FFFFFF"/>
+                </a:solidFill>
+                <a:latin typeface="Lato"/>
+              </a:rPr>
+              <a:t>Transformez votre DUERP en outil de pilotage vivant, connecté à vos accidents réels.</a:t>
+            </a:r>
+          </a:p>
+          <a:p>
+            <a:pPr algn="l"/>
+            <a:r>
+              <a:rPr sz="1499" b="0" i="0">
+                <a:solidFill>
+                  <a:srgbClr val="FFFFFF"/>
+                </a:solidFill>
+                <a:latin typeface="Lato"/>
+              </a:rPr>
+              <a:t>Réduisez votre sinistralité et maîtrisez vos cotisations AT/MP.</a:t>
+            </a:r>
+          </a:p>
+        </p:txBody>
+      </p:sp>
     </p:spTree>
   </p:cSld>
   <p:clrMapOvr>
@@ -3169,6 +3251,181 @@
           </a:prstGeom>
         </p:spPr>
       </p:pic>
+      <p:sp>
+        <p:nvSpPr>
+          <p:cNvPr id="3" name="TextBox 2"/>
+          <p:cNvSpPr txBox="1"/>
+          <p:nvPr/>
+        </p:nvSpPr>
+        <p:spPr>
+          <a:xfrm>
+            <a:off x="952476" y="1475445"/>
+            <a:ext cx="4771012" cy="872408"/>
+          </a:xfrm>
+          <a:prstGeom prst="rect">
+            <a:avLst/>
+          </a:prstGeom>
+          <a:noFill/>
+        </p:spPr>
+        <p:txBody>
+          <a:bodyPr wrap="square" lIns="0" rIns="0" tIns="0" bIns="0" anchor="ctr">
+            <a:spAutoFit/>
+          </a:bodyPr>
+          <a:lstStyle/>
+          <a:p>
+            <a:pPr algn="l"/>
+            <a:r>
+              <a:rPr sz="2849" b="1" i="0">
+                <a:solidFill>
+                  <a:srgbClr val="0F172A"/>
+                </a:solidFill>
+                <a:latin typeface="Lato"/>
+              </a:rPr>
+              <a:t>Une prévention qui réduit vos accidents</a:t>
+            </a:r>
+          </a:p>
+        </p:txBody>
+      </p:sp>
+      <p:sp>
+        <p:nvSpPr>
+          <p:cNvPr id="4" name="TextBox 3"/>
+          <p:cNvSpPr txBox="1"/>
+          <p:nvPr/>
+        </p:nvSpPr>
+        <p:spPr>
+          <a:xfrm>
+            <a:off x="1352516" y="2658301"/>
+            <a:ext cx="4424102" cy="442901"/>
+          </a:xfrm>
+          <a:prstGeom prst="rect">
+            <a:avLst/>
+          </a:prstGeom>
+          <a:noFill/>
+        </p:spPr>
+        <p:txBody>
+          <a:bodyPr wrap="square" lIns="0" rIns="0" tIns="0" bIns="0" anchor="ctr">
+            <a:spAutoFit/>
+          </a:bodyPr>
+          <a:lstStyle/>
+          <a:p>
+            <a:pPr algn="l"/>
+            <a:r>
+              <a:rPr sz="1274" b="0" i="0">
+                <a:solidFill>
+                  <a:srgbClr val="0F172A"/>
+                </a:solidFill>
+                <a:latin typeface="Lato"/>
+              </a:rPr>
+              <a:t>Cibler les risques qui causent réellement vos accidents, pas une liste générique</a:t>
+            </a:r>
+          </a:p>
+        </p:txBody>
+      </p:sp>
+      <p:sp>
+        <p:nvSpPr>
+          <p:cNvPr id="5" name="TextBox 4"/>
+          <p:cNvSpPr txBox="1"/>
+          <p:nvPr/>
+        </p:nvSpPr>
+        <p:spPr>
+          <a:xfrm>
+            <a:off x="1352516" y="3334559"/>
+            <a:ext cx="4389426" cy="442901"/>
+          </a:xfrm>
+          <a:prstGeom prst="rect">
+            <a:avLst/>
+          </a:prstGeom>
+          <a:noFill/>
+        </p:spPr>
+        <p:txBody>
+          <a:bodyPr wrap="square" lIns="0" rIns="0" tIns="0" bIns="0" anchor="ctr">
+            <a:spAutoFit/>
+          </a:bodyPr>
+          <a:lstStyle/>
+          <a:p>
+            <a:pPr algn="l"/>
+            <a:r>
+              <a:rPr sz="1274" b="0" i="0">
+                <a:solidFill>
+                  <a:srgbClr val="0F172A"/>
+                </a:solidFill>
+                <a:latin typeface="Lato"/>
+              </a:rPr>
+              <a:t>Réduire la fréquence et la gravité des accidents par des actions priorisées</a:t>
+            </a:r>
+          </a:p>
+        </p:txBody>
+      </p:sp>
+      <p:sp>
+        <p:nvSpPr>
+          <p:cNvPr id="6" name="TextBox 5"/>
+          <p:cNvSpPr txBox="1"/>
+          <p:nvPr/>
+        </p:nvSpPr>
+        <p:spPr>
+          <a:xfrm>
+            <a:off x="1352516" y="4010817"/>
+            <a:ext cx="4346119" cy="200019"/>
+          </a:xfrm>
+          <a:prstGeom prst="rect">
+            <a:avLst/>
+          </a:prstGeom>
+          <a:noFill/>
+        </p:spPr>
+        <p:txBody>
+          <a:bodyPr wrap="square" lIns="0" rIns="0" tIns="0" bIns="0" anchor="ctr">
+            <a:spAutoFit/>
+          </a:bodyPr>
+          <a:lstStyle/>
+          <a:p>
+            <a:pPr algn="l"/>
+            <a:r>
+              <a:rPr sz="1274" b="0" i="0">
+                <a:solidFill>
+                  <a:srgbClr val="0F172A"/>
+                </a:solidFill>
+                <a:latin typeface="Lato"/>
+              </a:rPr>
+              <a:t>Mesurer l'effet de votre prévention dans le temps, site par site</a:t>
+            </a:r>
+          </a:p>
+        </p:txBody>
+      </p:sp>
+      <p:sp>
+        <p:nvSpPr>
+          <p:cNvPr id="7" name="TextBox 6"/>
+          <p:cNvSpPr txBox="1"/>
+          <p:nvPr/>
+        </p:nvSpPr>
+        <p:spPr>
+          <a:xfrm>
+            <a:off x="1352516" y="4468006"/>
+            <a:ext cx="4226017" cy="442901"/>
+          </a:xfrm>
+          <a:prstGeom prst="rect">
+            <a:avLst/>
+          </a:prstGeom>
+          <a:noFill/>
+        </p:spPr>
+        <p:txBody>
+          <a:bodyPr wrap="square" lIns="0" rIns="0" tIns="0" bIns="0" anchor="ctr">
+            <a:spAutoFit/>
+          </a:bodyPr>
+          <a:lstStyle/>
+          <a:p>
+            <a:pPr algn="l"/>
+            <a:r>
+              <a:rPr sz="1274" b="0" i="0">
+                <a:solidFill>
+                  <a:srgbClr val="0F172A"/>
+                </a:solidFill>
+                <a:latin typeface="Lato"/>
+              </a:rPr>
+              <a:t>Une démarche que vous pouvez présenter à votre service de santé au travail et à l'inspection</a:t>
+            </a:r>
+          </a:p>
+        </p:txBody>
+      </p:sp>
     </p:spTree>
   </p:cSld>
   <p:clrMapOvr>
@@ -3307,6 +3564,196 @@
           </a:p>
         </p:txBody>
       </p:sp>
+      <p:sp>
+        <p:nvSpPr>
+          <p:cNvPr id="5" name="TextBox 4"/>
+          <p:cNvSpPr txBox="1"/>
+          <p:nvPr/>
+        </p:nvSpPr>
+        <p:spPr>
+          <a:xfrm>
+            <a:off x="1665493" y="1135381"/>
+            <a:ext cx="9241548" cy="495287"/>
+          </a:xfrm>
+          <a:prstGeom prst="rect">
+            <a:avLst/>
+          </a:prstGeom>
+          <a:noFill/>
+        </p:spPr>
+        <p:txBody>
+          <a:bodyPr wrap="square" lIns="0" rIns="0" tIns="0" bIns="0" anchor="ctr">
+            <a:spAutoFit/>
+          </a:bodyPr>
+          <a:lstStyle/>
+          <a:p>
+            <a:pPr algn="ctr"/>
+            <a:r>
+              <a:rPr sz="3300" b="1" i="0">
+                <a:solidFill>
+                  <a:srgbClr val="0F172A"/>
+                </a:solidFill>
+                <a:latin typeface="Lato"/>
+              </a:rPr>
+              <a:t>Aller plus loin dans votre démarche de prévention</a:t>
+            </a:r>
+          </a:p>
+        </p:txBody>
+      </p:sp>
+      <p:sp>
+        <p:nvSpPr>
+          <p:cNvPr id="6" name="TextBox 5"/>
+          <p:cNvSpPr txBox="1"/>
+          <p:nvPr/>
+        </p:nvSpPr>
+        <p:spPr>
+          <a:xfrm>
+            <a:off x="2971130" y="2986012"/>
+            <a:ext cx="6574913" cy="2265851"/>
+          </a:xfrm>
+          <a:prstGeom prst="rect">
+            <a:avLst/>
+          </a:prstGeom>
+          <a:noFill/>
+        </p:spPr>
+        <p:txBody>
+          <a:bodyPr wrap="square" lIns="0" rIns="0" tIns="0" bIns="0" anchor="ctr">
+            <a:spAutoFit/>
+          </a:bodyPr>
+          <a:lstStyle/>
+          <a:p>
+            <a:pPr algn="ctr"/>
+            <a:r>
+              <a:rPr sz="1199" b="0" i="0">
+                <a:solidFill>
+                  <a:srgbClr val="0F172A"/>
+                </a:solidFill>
+                <a:latin typeface="Lato"/>
+              </a:rPr>
+              <a:t>Découvrir cette offre</a:t>
+            </a:r>
+          </a:p>
+          <a:p>
+            <a:pPr algn="ctr"/>
+            <a:r>
+              <a:rPr sz="1199" b="0" i="0">
+                <a:solidFill>
+                  <a:srgbClr val="0F172A"/>
+                </a:solidFill>
+                <a:latin typeface="Lato"/>
+              </a:rPr>
+              <a:t>EN OPTION</a:t>
+            </a:r>
+          </a:p>
+          <a:p>
+            <a:pPr algn="ctr"/>
+            <a:r>
+              <a:rPr sz="1199" b="0" i="0">
+                <a:solidFill>
+                  <a:srgbClr val="0F172A"/>
+                </a:solidFill>
+                <a:latin typeface="Lato"/>
+              </a:rPr>
+              <a:t>Gestion des AT/MP</a:t>
+            </a:r>
+          </a:p>
+          <a:p>
+            <a:pPr algn="ctr"/>
+            <a:r>
+              <a:rPr sz="1199" b="0" i="0">
+                <a:solidFill>
+                  <a:srgbClr val="0F172A"/>
+                </a:solidFill>
+                <a:latin typeface="Lato"/>
+              </a:rPr>
+              <a:t/>
+            </a:r>
+          </a:p>
+          <a:p>
+            <a:pPr algn="ctr"/>
+            <a:r>
+              <a:rPr sz="1199" b="0" i="0">
+                <a:solidFill>
+                  <a:srgbClr val="0F172A"/>
+                </a:solidFill>
+                <a:latin typeface="Lato"/>
+              </a:rPr>
+              <a:t>Déclarer, défendre et piloter vos AT/MP, l'aval naturel d'une prévention pilotée.</a:t>
+            </a:r>
+          </a:p>
+          <a:p>
+            <a:pPr algn="ctr"/>
+            <a:r>
+              <a:rPr sz="1199" b="0" i="0">
+                <a:solidFill>
+                  <a:srgbClr val="0F172A"/>
+                </a:solidFill>
+                <a:latin typeface="Lato"/>
+              </a:rPr>
+              <a:t/>
+            </a:r>
+          </a:p>
+          <a:p>
+            <a:pPr algn="ctr"/>
+            <a:r>
+              <a:rPr sz="1199" b="0" i="0">
+                <a:solidFill>
+                  <a:srgbClr val="0F172A"/>
+                </a:solidFill>
+                <a:latin typeface="Lato"/>
+              </a:rPr>
+              <a:t>Découvrir cette offre</a:t>
+            </a:r>
+          </a:p>
+          <a:p>
+            <a:pPr algn="ctr"/>
+            <a:r>
+              <a:rPr sz="1199" b="0" i="0">
+                <a:solidFill>
+                  <a:srgbClr val="0F172A"/>
+                </a:solidFill>
+                <a:latin typeface="Lato"/>
+              </a:rPr>
+              <a:t>EN OPTION</a:t>
+            </a:r>
+          </a:p>
+          <a:p>
+            <a:pPr algn="ctr"/>
+            <a:r>
+              <a:rPr sz="1199" b="0" i="0">
+                <a:solidFill>
+                  <a:srgbClr val="0F172A"/>
+                </a:solidFill>
+                <a:latin typeface="Lato"/>
+              </a:rPr>
+              <a:t>Gérer les visites médicales</a:t>
+            </a:r>
+          </a:p>
+          <a:p>
+            <a:pPr algn="ctr"/>
+            <a:r>
+              <a:rPr sz="1199" b="0" i="0">
+                <a:solidFill>
+                  <a:srgbClr val="0F172A"/>
+                </a:solidFill>
+                <a:latin typeface="Lato"/>
+              </a:rPr>
+              <a:t/>
+            </a:r>
+          </a:p>
+          <a:p>
+            <a:pPr algn="ctr"/>
+            <a:r>
+              <a:rPr sz="1199" b="0" i="0">
+                <a:solidFill>
+                  <a:srgbClr val="0F172A"/>
+                </a:solidFill>
+                <a:latin typeface="Lato"/>
+              </a:rPr>
+              <a:t>Externaliser le suivi des visites médicales, le maillon santé au travail de votre prévention.</a:t>
+            </a:r>
+          </a:p>
+        </p:txBody>
+      </p:sp>
     </p:spTree>
   </p:cSld>
   <p:clrMapOvr>
@@ -3397,6 +3844,216 @@
           </a:p>
         </p:txBody>
       </p:sp>
+      <p:sp>
+        <p:nvSpPr>
+          <p:cNvPr id="4" name="TextBox 3"/>
+          <p:cNvSpPr txBox="1"/>
+          <p:nvPr/>
+        </p:nvSpPr>
+        <p:spPr>
+          <a:xfrm>
+            <a:off x="4204140" y="1243874"/>
+            <a:ext cx="4164404" cy="495287"/>
+          </a:xfrm>
+          <a:prstGeom prst="rect">
+            <a:avLst/>
+          </a:prstGeom>
+          <a:noFill/>
+        </p:spPr>
+        <p:txBody>
+          <a:bodyPr wrap="square" lIns="0" rIns="0" tIns="0" bIns="0" anchor="ctr">
+            <a:spAutoFit/>
+          </a:bodyPr>
+          <a:lstStyle/>
+          <a:p>
+            <a:pPr algn="ctr"/>
+            <a:r>
+              <a:rPr sz="3301" b="1" i="0">
+                <a:solidFill>
+                  <a:srgbClr val="0F172A"/>
+                </a:solidFill>
+                <a:latin typeface="Lato"/>
+              </a:rPr>
+              <a:t>Ils nous font confiance</a:t>
+            </a:r>
+          </a:p>
+        </p:txBody>
+      </p:sp>
+      <p:sp>
+        <p:nvSpPr>
+          <p:cNvPr id="5" name="TextBox 4"/>
+          <p:cNvSpPr txBox="1"/>
+          <p:nvPr/>
+        </p:nvSpPr>
+        <p:spPr>
+          <a:xfrm>
+            <a:off x="1047723" y="2251564"/>
+            <a:ext cx="1142971" cy="228594"/>
+          </a:xfrm>
+          <a:prstGeom prst="rect">
+            <a:avLst/>
+          </a:prstGeom>
+          <a:noFill/>
+        </p:spPr>
+        <p:txBody>
+          <a:bodyPr wrap="square" lIns="0" rIns="0" tIns="0" bIns="0" anchor="ctr">
+            <a:spAutoFit/>
+          </a:bodyPr>
+          <a:lstStyle/>
+          <a:p>
+            <a:pPr algn="l"/>
+            <a:r>
+              <a:rPr sz="1499" b="0" i="0">
+                <a:solidFill>
+                  <a:srgbClr val="FBBF24"/>
+                </a:solidFill>
+                <a:latin typeface="Lato"/>
+              </a:rPr>
+              <a:t>★★★★★</a:t>
+            </a:r>
+          </a:p>
+        </p:txBody>
+      </p:sp>
+      <p:sp>
+        <p:nvSpPr>
+          <p:cNvPr id="6" name="TextBox 5"/>
+          <p:cNvSpPr txBox="1"/>
+          <p:nvPr/>
+        </p:nvSpPr>
+        <p:spPr>
+          <a:xfrm>
+            <a:off x="1314417" y="2784951"/>
+            <a:ext cx="4672193" cy="552436"/>
+          </a:xfrm>
+          <a:prstGeom prst="rect">
+            <a:avLst/>
+          </a:prstGeom>
+          <a:noFill/>
+        </p:spPr>
+        <p:txBody>
+          <a:bodyPr wrap="square" lIns="0" rIns="0" tIns="0" bIns="0" anchor="ctr">
+            <a:spAutoFit/>
+          </a:bodyPr>
+          <a:lstStyle/>
+          <a:p>
+            <a:pPr algn="l"/>
+            <a:r>
+              <a:rPr sz="1499" b="0" i="1">
+                <a:solidFill>
+                  <a:srgbClr val="0F172A"/>
+                </a:solidFill>
+                <a:latin typeface="Lato"/>
+              </a:rPr>
+              <a:t>Une des spécificités les plus utiles de la plate-forme est l'accès à l'information de manière instantanée.</a:t>
+            </a:r>
+          </a:p>
+        </p:txBody>
+      </p:sp>
+      <p:sp>
+        <p:nvSpPr>
+          <p:cNvPr id="7" name="TextBox 6"/>
+          <p:cNvSpPr txBox="1"/>
+          <p:nvPr/>
+        </p:nvSpPr>
+        <p:spPr>
+          <a:xfrm>
+            <a:off x="1047723" y="3651704"/>
+            <a:ext cx="902024" cy="209544"/>
+          </a:xfrm>
+          <a:prstGeom prst="rect">
+            <a:avLst/>
+          </a:prstGeom>
+          <a:noFill/>
+        </p:spPr>
+        <p:txBody>
+          <a:bodyPr wrap="square" lIns="0" rIns="0" tIns="0" bIns="0" anchor="ctr">
+            <a:spAutoFit/>
+          </a:bodyPr>
+          <a:lstStyle/>
+          <a:p>
+            <a:pPr algn="l"/>
+            <a:r>
+              <a:rPr sz="1345" b="1" i="0">
+                <a:solidFill>
+                  <a:srgbClr val="0F172A"/>
+                </a:solidFill>
+                <a:latin typeface="Lato"/>
+              </a:rPr>
+              <a:t>Paul Bichon</a:t>
+            </a:r>
+          </a:p>
+        </p:txBody>
+      </p:sp>
+      <p:sp>
+        <p:nvSpPr>
+          <p:cNvPr id="8" name="TextBox 7"/>
+          <p:cNvSpPr txBox="1"/>
+          <p:nvPr/>
+        </p:nvSpPr>
+        <p:spPr>
+          <a:xfrm>
+            <a:off x="1047723" y="3899348"/>
+            <a:ext cx="4071240" cy="161920"/>
+          </a:xfrm>
+          <a:prstGeom prst="rect">
+            <a:avLst/>
+          </a:prstGeom>
+          <a:noFill/>
+        </p:spPr>
+        <p:txBody>
+          <a:bodyPr wrap="square" lIns="0" rIns="0" tIns="0" bIns="0" anchor="ctr">
+            <a:spAutoFit/>
+          </a:bodyPr>
+          <a:lstStyle/>
+          <a:p>
+            <a:pPr algn="l"/>
+            <a:r>
+              <a:rPr sz="1049" b="0" i="0">
+                <a:solidFill>
+                  <a:srgbClr val="6B7280"/>
+                </a:solidFill>
+                <a:latin typeface="Lato"/>
+              </a:rPr>
+              <a:t>Responsable Sécurité du Personnel et Environnement, Euro Cargo Rail</a:t>
+            </a:r>
+          </a:p>
+        </p:txBody>
+      </p:sp>
+      <p:sp>
+        <p:nvSpPr>
+          <p:cNvPr id="9" name="TextBox 8"/>
+          <p:cNvSpPr txBox="1"/>
+          <p:nvPr/>
+        </p:nvSpPr>
+        <p:spPr>
+          <a:xfrm>
+            <a:off x="1276318" y="4899448"/>
+            <a:ext cx="1091775" cy="161920"/>
+          </a:xfrm>
+          <a:prstGeom prst="rect">
+            <a:avLst/>
+          </a:prstGeom>
+          <a:noFill/>
+        </p:spPr>
+        <p:txBody>
+          <a:bodyPr wrap="square" lIns="0" rIns="0" tIns="0" bIns="0" anchor="ctr">
+            <a:spAutoFit/>
+          </a:bodyPr>
+          <a:lstStyle/>
+          <a:p>
+            <a:pPr algn="l"/>
+            <a:r>
+              <a:rPr sz="1047" b="1" i="0">
+                <a:solidFill>
+                  <a:srgbClr val="FFFFFF"/>
+                </a:solidFill>
+                <a:latin typeface="Lato"/>
+              </a:rPr>
+              <a:t>Lire le témoignage</a:t>
+            </a:r>
+          </a:p>
+        </p:txBody>
+      </p:sp>
     </p:spTree>
   </p:cSld>
   <p:clrMapOvr>
@@ -3439,6 +4096,111 @@
           </a:prstGeom>
         </p:spPr>
       </p:pic>
+      <p:sp>
+        <p:nvSpPr>
+          <p:cNvPr id="3" name="TextBox 2"/>
+          <p:cNvSpPr txBox="1"/>
+          <p:nvPr/>
+        </p:nvSpPr>
+        <p:spPr>
+          <a:xfrm>
+            <a:off x="1047723" y="1610428"/>
+            <a:ext cx="3449898" cy="998165"/>
+          </a:xfrm>
+          <a:prstGeom prst="rect">
+            <a:avLst/>
+          </a:prstGeom>
+          <a:noFill/>
+        </p:spPr>
+        <p:txBody>
+          <a:bodyPr wrap="square" lIns="0" rIns="0" tIns="0" bIns="0" anchor="ctr">
+            <a:spAutoFit/>
+          </a:bodyPr>
+          <a:lstStyle/>
+          <a:p>
+            <a:pPr algn="l"/>
+            <a:r>
+              <a:rPr sz="3299" b="1" i="0">
+                <a:solidFill>
+                  <a:srgbClr val="0F172A"/>
+                </a:solidFill>
+                <a:latin typeface="Lato"/>
+              </a:rPr>
+              <a:t>Un fort ancrage en France...</a:t>
+            </a:r>
+          </a:p>
+        </p:txBody>
+      </p:sp>
+      <p:sp>
+        <p:nvSpPr>
+          <p:cNvPr id="4" name="TextBox 3"/>
+          <p:cNvSpPr txBox="1"/>
+          <p:nvPr/>
+        </p:nvSpPr>
+        <p:spPr>
+          <a:xfrm>
+            <a:off x="1047723" y="2911451"/>
+            <a:ext cx="4298197" cy="750372"/>
+          </a:xfrm>
+          <a:prstGeom prst="rect">
+            <a:avLst/>
+          </a:prstGeom>
+          <a:noFill/>
+        </p:spPr>
+        <p:txBody>
+          <a:bodyPr wrap="square" lIns="0" rIns="0" tIns="0" bIns="0" anchor="ctr">
+            <a:spAutoFit/>
+          </a:bodyPr>
+          <a:lstStyle/>
+          <a:p>
+            <a:pPr algn="l"/>
+            <a:r>
+              <a:rPr sz="1274" b="0" i="0">
+                <a:solidFill>
+                  <a:srgbClr val="6B7280"/>
+                </a:solidFill>
+                <a:latin typeface="Lato"/>
+              </a:rPr>
+              <a:t>Nos équipes locales accompagnent au quotidien nos clients dans leur développement et leurs transformations en s'appuyant sur un écosystème de professionnels en régions :</a:t>
+            </a:r>
+          </a:p>
+        </p:txBody>
+      </p:sp>
+      <p:sp>
+        <p:nvSpPr>
+          <p:cNvPr id="5" name="TextBox 4"/>
+          <p:cNvSpPr txBox="1"/>
+          <p:nvPr/>
+        </p:nvSpPr>
+        <p:spPr>
+          <a:xfrm>
+            <a:off x="1047723" y="3736980"/>
+            <a:ext cx="4285845" cy="1025548"/>
+          </a:xfrm>
+          <a:prstGeom prst="rect">
+            <a:avLst/>
+          </a:prstGeom>
+          <a:noFill/>
+        </p:spPr>
+        <p:txBody>
+          <a:bodyPr wrap="square" lIns="0" rIns="0" tIns="0" bIns="0" anchor="ctr">
+            <a:spAutoFit/>
+          </a:bodyPr>
+          <a:lstStyle/>
+          <a:p>
+            <a:pPr algn="l"/>
+            <a:r>
+              <a:rPr sz="1274" b="0" i="0">
+                <a:solidFill>
+                  <a:srgbClr val="6B7280"/>
+                </a:solidFill>
+                <a:latin typeface="Lato"/>
+              </a:rPr>
+              <a:t>experts scientifiques, experts comptables, établissements bancaires, pôles de compétitivité, fédérations professionnelles, avec un maillage de cabinets d'avocats et de médecins indépendants.</a:t>
+            </a:r>
+          </a:p>
+        </p:txBody>
+      </p:sp>
     </p:spTree>
   </p:cSld>
   <p:clrMapOvr>
@@ -3481,6 +4243,41 @@
           </a:prstGeom>
         </p:spPr>
       </p:pic>
+      <p:sp>
+        <p:nvSpPr>
+          <p:cNvPr id="3" name="TextBox 2"/>
+          <p:cNvSpPr txBox="1"/>
+          <p:nvPr/>
+        </p:nvSpPr>
+        <p:spPr>
+          <a:xfrm>
+            <a:off x="1436899" y="516420"/>
+            <a:ext cx="9698737" cy="998165"/>
+          </a:xfrm>
+          <a:prstGeom prst="rect">
+            <a:avLst/>
+          </a:prstGeom>
+          <a:noFill/>
+        </p:spPr>
+        <p:txBody>
+          <a:bodyPr wrap="square" lIns="0" rIns="0" tIns="0" bIns="0" anchor="ctr">
+            <a:spAutoFit/>
+          </a:bodyPr>
+          <a:lstStyle/>
+          <a:p>
+            <a:pPr algn="ctr"/>
+            <a:r>
+              <a:rPr sz="3299" b="1" i="0">
+                <a:solidFill>
+                  <a:srgbClr val="0F172A"/>
+                </a:solidFill>
+                <a:latin typeface="Lato"/>
+              </a:rPr>
+              <a:t>... avec des bureaux dans 14 pays pour une proximité accrue avec nos clients et leur écosystème</a:t>
+            </a:r>
+          </a:p>
+        </p:txBody>
+      </p:sp>
     </p:spTree>
   </p:cSld>
   <p:clrMapOvr>
@@ -3523,6 +4320,321 @@
           </a:prstGeom>
         </p:spPr>
       </p:pic>
+      <p:sp>
+        <p:nvSpPr>
+          <p:cNvPr id="3" name="TextBox 2"/>
+          <p:cNvSpPr txBox="1"/>
+          <p:nvPr/>
+        </p:nvSpPr>
+        <p:spPr>
+          <a:xfrm>
+            <a:off x="3800231" y="555859"/>
+            <a:ext cx="4972223" cy="495287"/>
+          </a:xfrm>
+          <a:prstGeom prst="rect">
+            <a:avLst/>
+          </a:prstGeom>
+          <a:noFill/>
+        </p:spPr>
+        <p:txBody>
+          <a:bodyPr wrap="square" lIns="0" rIns="0" tIns="0" bIns="0" anchor="ctr">
+            <a:spAutoFit/>
+          </a:bodyPr>
+          <a:lstStyle/>
+          <a:p>
+            <a:pPr algn="ctr"/>
+            <a:r>
+              <a:rPr sz="3300" b="1" i="0">
+                <a:solidFill>
+                  <a:srgbClr val="0F172A"/>
+                </a:solidFill>
+                <a:latin typeface="Lato"/>
+              </a:rPr>
+              <a:t>Questions qu'on nous pose</a:t>
+            </a:r>
+          </a:p>
+        </p:txBody>
+      </p:sp>
+      <p:sp>
+        <p:nvSpPr>
+          <p:cNvPr id="4" name="TextBox 3"/>
+          <p:cNvSpPr txBox="1"/>
+          <p:nvPr/>
+        </p:nvSpPr>
+        <p:spPr>
+          <a:xfrm>
+            <a:off x="1876378" y="1930252"/>
+            <a:ext cx="1952873" cy="200019"/>
+          </a:xfrm>
+          <a:prstGeom prst="rect">
+            <a:avLst/>
+          </a:prstGeom>
+          <a:noFill/>
+        </p:spPr>
+        <p:txBody>
+          <a:bodyPr wrap="square" lIns="0" rIns="0" tIns="0" bIns="0" anchor="ctr">
+            <a:spAutoFit/>
+          </a:bodyPr>
+          <a:lstStyle/>
+          <a:p>
+            <a:pPr algn="l"/>
+            <a:r>
+              <a:rPr sz="1274" b="1" i="0">
+                <a:solidFill>
+                  <a:srgbClr val="0DA4E8"/>
+                </a:solidFill>
+                <a:latin typeface="Lato"/>
+              </a:rPr>
+              <a:t>Nous avons déjà un DUERP</a:t>
+            </a:r>
+          </a:p>
+        </p:txBody>
+      </p:sp>
+      <p:sp>
+        <p:nvSpPr>
+          <p:cNvPr id="5" name="TextBox 4"/>
+          <p:cNvSpPr txBox="1"/>
+          <p:nvPr/>
+        </p:nvSpPr>
+        <p:spPr>
+          <a:xfrm>
+            <a:off x="1476338" y="2335054"/>
+            <a:ext cx="4200568" cy="657208"/>
+          </a:xfrm>
+          <a:prstGeom prst="rect">
+            <a:avLst/>
+          </a:prstGeom>
+          <a:noFill/>
+        </p:spPr>
+        <p:txBody>
+          <a:bodyPr wrap="square" lIns="0" rIns="0" tIns="0" bIns="0" anchor="ctr">
+            <a:spAutoFit/>
+          </a:bodyPr>
+          <a:lstStyle/>
+          <a:p>
+            <a:pPr algn="l"/>
+            <a:r>
+              <a:rPr sz="1124" b="0" i="0">
+                <a:solidFill>
+                  <a:srgbClr val="6B7280"/>
+                </a:solidFill>
+                <a:latin typeface="Lato"/>
+              </a:rPr>
+              <a:t>La question n'est pas d'avoir un DUERP, c'est qu'il soit vivant. Un document rempli une fois puis classé ne réduit aucun risque. Notre logiciel le maintient à jour en continu et le relie à vos accidents réels.</a:t>
+            </a:r>
+          </a:p>
+        </p:txBody>
+      </p:sp>
+      <p:sp>
+        <p:nvSpPr>
+          <p:cNvPr id="6" name="TextBox 5"/>
+          <p:cNvSpPr txBox="1"/>
+          <p:nvPr/>
+        </p:nvSpPr>
+        <p:spPr>
+          <a:xfrm>
+            <a:off x="7286442" y="1930252"/>
+            <a:ext cx="3479663" cy="200019"/>
+          </a:xfrm>
+          <a:prstGeom prst="rect">
+            <a:avLst/>
+          </a:prstGeom>
+          <a:noFill/>
+        </p:spPr>
+        <p:txBody>
+          <a:bodyPr wrap="square" lIns="0" rIns="0" tIns="0" bIns="0" anchor="ctr">
+            <a:spAutoFit/>
+          </a:bodyPr>
+          <a:lstStyle/>
+          <a:p>
+            <a:pPr algn="l"/>
+            <a:r>
+              <a:rPr sz="1274" b="1" i="0">
+                <a:solidFill>
+                  <a:srgbClr val="0DA4E8"/>
+                </a:solidFill>
+                <a:latin typeface="Lato"/>
+              </a:rPr>
+              <a:t>Est-ce que vous rédigez le DUERP à notre place ?</a:t>
+            </a:r>
+          </a:p>
+        </p:txBody>
+      </p:sp>
+      <p:sp>
+        <p:nvSpPr>
+          <p:cNvPr id="7" name="TextBox 6"/>
+          <p:cNvSpPr txBox="1"/>
+          <p:nvPr/>
+        </p:nvSpPr>
+        <p:spPr>
+          <a:xfrm>
+            <a:off x="6886402" y="2335054"/>
+            <a:ext cx="3911105" cy="657208"/>
+          </a:xfrm>
+          <a:prstGeom prst="rect">
+            <a:avLst/>
+          </a:prstGeom>
+          <a:noFill/>
+        </p:spPr>
+        <p:txBody>
+          <a:bodyPr wrap="square" lIns="0" rIns="0" tIns="0" bIns="0" anchor="ctr">
+            <a:spAutoFit/>
+          </a:bodyPr>
+          <a:lstStyle/>
+          <a:p>
+            <a:pPr algn="l"/>
+            <a:r>
+              <a:rPr sz="1124" b="0" i="0">
+                <a:solidFill>
+                  <a:srgbClr val="6B7280"/>
+                </a:solidFill>
+                <a:latin typeface="Lato"/>
+              </a:rPr>
+              <a:t>Non. Le logiciel outille et accompagne le pilotage de votre démarche. Le contenu du DUERP et les décisions de prévention restent de votre responsabilité.</a:t>
+            </a:r>
+          </a:p>
+        </p:txBody>
+      </p:sp>
+      <p:sp>
+        <p:nvSpPr>
+          <p:cNvPr id="8" name="TextBox 7"/>
+          <p:cNvSpPr txBox="1"/>
+          <p:nvPr/>
+        </p:nvSpPr>
+        <p:spPr>
+          <a:xfrm>
+            <a:off x="1876378" y="4144759"/>
+            <a:ext cx="2249778" cy="200019"/>
+          </a:xfrm>
+          <a:prstGeom prst="rect">
+            <a:avLst/>
+          </a:prstGeom>
+          <a:noFill/>
+        </p:spPr>
+        <p:txBody>
+          <a:bodyPr wrap="square" lIns="0" rIns="0" tIns="0" bIns="0" anchor="ctr">
+            <a:spAutoFit/>
+          </a:bodyPr>
+          <a:lstStyle/>
+          <a:p>
+            <a:pPr algn="l"/>
+            <a:r>
+              <a:rPr sz="1274" b="1" i="0">
+                <a:solidFill>
+                  <a:srgbClr val="0DA4E8"/>
+                </a:solidFill>
+                <a:latin typeface="Lato"/>
+              </a:rPr>
+              <a:t>En quoi est-ce lié à nos AT/MP ?</a:t>
+            </a:r>
+          </a:p>
+        </p:txBody>
+      </p:sp>
+      <p:sp>
+        <p:nvSpPr>
+          <p:cNvPr id="9" name="TextBox 8"/>
+          <p:cNvSpPr txBox="1"/>
+          <p:nvPr/>
+        </p:nvSpPr>
+        <p:spPr>
+          <a:xfrm>
+            <a:off x="1476338" y="4549561"/>
+            <a:ext cx="4043410" cy="900089"/>
+          </a:xfrm>
+          <a:prstGeom prst="rect">
+            <a:avLst/>
+          </a:prstGeom>
+          <a:noFill/>
+        </p:spPr>
+        <p:txBody>
+          <a:bodyPr wrap="square" lIns="0" rIns="0" tIns="0" bIns="0" anchor="ctr">
+            <a:spAutoFit/>
+          </a:bodyPr>
+          <a:lstStyle/>
+          <a:p>
+            <a:pPr algn="l"/>
+            <a:r>
+              <a:rPr sz="1124" b="0" i="0">
+                <a:solidFill>
+                  <a:srgbClr val="6B7280"/>
+                </a:solidFill>
+                <a:latin typeface="Lato"/>
+              </a:rPr>
+              <a:t>Le logiciel relie l'évaluation des risques à votre sinistralité réelle (écosystème Acciline+). Les risques qui causent vraiment vos accidents sont priorisés, et la prévention ciblée nourrit la maîtrise de votre taux AT/MP.</a:t>
+            </a:r>
+          </a:p>
+        </p:txBody>
+      </p:sp>
+      <p:sp>
+        <p:nvSpPr>
+          <p:cNvPr id="10" name="TextBox 9"/>
+          <p:cNvSpPr txBox="1"/>
+          <p:nvPr/>
+        </p:nvSpPr>
+        <p:spPr>
+          <a:xfrm>
+            <a:off x="7286442" y="4144759"/>
+            <a:ext cx="2775575" cy="200019"/>
+          </a:xfrm>
+          <a:prstGeom prst="rect">
+            <a:avLst/>
+          </a:prstGeom>
+          <a:noFill/>
+        </p:spPr>
+        <p:txBody>
+          <a:bodyPr wrap="square" lIns="0" rIns="0" tIns="0" bIns="0" anchor="ctr">
+            <a:spAutoFit/>
+          </a:bodyPr>
+          <a:lstStyle/>
+          <a:p>
+            <a:pPr algn="l"/>
+            <a:r>
+              <a:rPr sz="1274" b="1" i="0">
+                <a:solidFill>
+                  <a:srgbClr val="0DA4E8"/>
+                </a:solidFill>
+                <a:latin typeface="Lato"/>
+              </a:rPr>
+              <a:t>Faut-il tout ressaisir pour chaque site ?</a:t>
+            </a:r>
+          </a:p>
+        </p:txBody>
+      </p:sp>
+      <p:sp>
+        <p:nvSpPr>
+          <p:cNvPr id="11" name="TextBox 10"/>
+          <p:cNvSpPr txBox="1"/>
+          <p:nvPr/>
+        </p:nvSpPr>
+        <p:spPr>
+          <a:xfrm>
+            <a:off x="6886402" y="4549561"/>
+            <a:ext cx="3971081" cy="657208"/>
+          </a:xfrm>
+          <a:prstGeom prst="rect">
+            <a:avLst/>
+          </a:prstGeom>
+          <a:noFill/>
+        </p:spPr>
+        <p:txBody>
+          <a:bodyPr wrap="square" lIns="0" rIns="0" tIns="0" bIns="0" anchor="ctr">
+            <a:spAutoFit/>
+          </a:bodyPr>
+          <a:lstStyle/>
+          <a:p>
+            <a:pPr algn="l"/>
+            <a:r>
+              <a:rPr sz="1124" b="0" i="0">
+                <a:solidFill>
+                  <a:srgbClr val="6B7280"/>
+                </a:solidFill>
+                <a:latin typeface="Lato"/>
+              </a:rPr>
+              <a:t>Non. Vous créez, dupliquez et mettez à jour vos évaluations d'un site à l'autre, et les actions correctives sont suivies en temps réel avec des alertes sur les échéances.</a:t>
+            </a:r>
+          </a:p>
+        </p:txBody>
+      </p:sp>
     </p:spTree>
   </p:cSld>
   <p:clrMapOvr>
@@ -3565,6 +4677,251 @@
           </a:prstGeom>
         </p:spPr>
       </p:pic>
+      <p:sp>
+        <p:nvSpPr>
+          <p:cNvPr id="3" name="TextBox 2"/>
+          <p:cNvSpPr txBox="1"/>
+          <p:nvPr/>
+        </p:nvSpPr>
+        <p:spPr>
+          <a:xfrm>
+            <a:off x="3822108" y="415368"/>
+            <a:ext cx="4928320" cy="495287"/>
+          </a:xfrm>
+          <a:prstGeom prst="rect">
+            <a:avLst/>
+          </a:prstGeom>
+          <a:noFill/>
+        </p:spPr>
+        <p:txBody>
+          <a:bodyPr wrap="square" lIns="0" rIns="0" tIns="0" bIns="0" anchor="ctr">
+            <a:spAutoFit/>
+          </a:bodyPr>
+          <a:lstStyle/>
+          <a:p>
+            <a:pPr algn="ctr"/>
+            <a:r>
+              <a:rPr sz="3302" b="1" i="0">
+                <a:solidFill>
+                  <a:srgbClr val="0F172A"/>
+                </a:solidFill>
+                <a:latin typeface="Lato"/>
+              </a:rPr>
+              <a:t>Ce dont nous avons besoin</a:t>
+            </a:r>
+          </a:p>
+        </p:txBody>
+      </p:sp>
+      <p:sp>
+        <p:nvSpPr>
+          <p:cNvPr id="4" name="TextBox 3"/>
+          <p:cNvSpPr txBox="1"/>
+          <p:nvPr/>
+        </p:nvSpPr>
+        <p:spPr>
+          <a:xfrm>
+            <a:off x="3286042" y="1823098"/>
+            <a:ext cx="3363580" cy="257168"/>
+          </a:xfrm>
+          <a:prstGeom prst="rect">
+            <a:avLst/>
+          </a:prstGeom>
+          <a:noFill/>
+        </p:spPr>
+        <p:txBody>
+          <a:bodyPr wrap="square" lIns="0" rIns="0" tIns="0" bIns="0" anchor="ctr">
+            <a:spAutoFit/>
+          </a:bodyPr>
+          <a:lstStyle/>
+          <a:p>
+            <a:pPr algn="l"/>
+            <a:r>
+              <a:rPr sz="1649" b="1" i="0">
+                <a:solidFill>
+                  <a:srgbClr val="0F172A"/>
+                </a:solidFill>
+                <a:latin typeface="Lato"/>
+              </a:rPr>
+              <a:t>Pour cadrer votre démarche DUERP</a:t>
+            </a:r>
+          </a:p>
+        </p:txBody>
+      </p:sp>
+      <p:sp>
+        <p:nvSpPr>
+          <p:cNvPr id="5" name="TextBox 4"/>
+          <p:cNvSpPr txBox="1"/>
+          <p:nvPr/>
+        </p:nvSpPr>
+        <p:spPr>
+          <a:xfrm>
+            <a:off x="3724181" y="2551743"/>
+            <a:ext cx="3339470" cy="200019"/>
+          </a:xfrm>
+          <a:prstGeom prst="rect">
+            <a:avLst/>
+          </a:prstGeom>
+          <a:noFill/>
+        </p:spPr>
+        <p:txBody>
+          <a:bodyPr wrap="square" lIns="0" rIns="0" tIns="0" bIns="0" anchor="ctr">
+            <a:spAutoFit/>
+          </a:bodyPr>
+          <a:lstStyle/>
+          <a:p>
+            <a:pPr algn="l"/>
+            <a:r>
+              <a:rPr sz="1274" b="0" i="0">
+                <a:solidFill>
+                  <a:srgbClr val="6B7280"/>
+                </a:solidFill>
+                <a:latin typeface="Lato"/>
+              </a:rPr>
+              <a:t>Périmètre des sites et unités de travail à couvrir</a:t>
+            </a:r>
+          </a:p>
+        </p:txBody>
+      </p:sp>
+      <p:sp>
+        <p:nvSpPr>
+          <p:cNvPr id="6" name="TextBox 5"/>
+          <p:cNvSpPr txBox="1"/>
+          <p:nvPr/>
+        </p:nvSpPr>
+        <p:spPr>
+          <a:xfrm>
+            <a:off x="3724181" y="3132753"/>
+            <a:ext cx="4103237" cy="200019"/>
+          </a:xfrm>
+          <a:prstGeom prst="rect">
+            <a:avLst/>
+          </a:prstGeom>
+          <a:noFill/>
+        </p:spPr>
+        <p:txBody>
+          <a:bodyPr wrap="square" lIns="0" rIns="0" tIns="0" bIns="0" anchor="ctr">
+            <a:spAutoFit/>
+          </a:bodyPr>
+          <a:lstStyle/>
+          <a:p>
+            <a:pPr algn="l"/>
+            <a:r>
+              <a:rPr sz="1274" b="0" i="0">
+                <a:solidFill>
+                  <a:srgbClr val="6B7280"/>
+                </a:solidFill>
+                <a:latin typeface="Lato"/>
+              </a:rPr>
+              <a:t>Votre DUERP actuel et vos supports d'évaluation existants</a:t>
+            </a:r>
+          </a:p>
+        </p:txBody>
+      </p:sp>
+      <p:sp>
+        <p:nvSpPr>
+          <p:cNvPr id="7" name="TextBox 6"/>
+          <p:cNvSpPr txBox="1"/>
+          <p:nvPr/>
+        </p:nvSpPr>
+        <p:spPr>
+          <a:xfrm>
+            <a:off x="3724181" y="3713764"/>
+            <a:ext cx="3318486" cy="200019"/>
+          </a:xfrm>
+          <a:prstGeom prst="rect">
+            <a:avLst/>
+          </a:prstGeom>
+          <a:noFill/>
+        </p:spPr>
+        <p:txBody>
+          <a:bodyPr wrap="square" lIns="0" rIns="0" tIns="0" bIns="0" anchor="ctr">
+            <a:spAutoFit/>
+          </a:bodyPr>
+          <a:lstStyle/>
+          <a:p>
+            <a:pPr algn="l"/>
+            <a:r>
+              <a:rPr sz="1274" b="0" i="0">
+                <a:solidFill>
+                  <a:srgbClr val="6B7280"/>
+                </a:solidFill>
+                <a:latin typeface="Lato"/>
+              </a:rPr>
+              <a:t>Vos données AT/MP récentes (sinistralité, taux)</a:t>
+            </a:r>
+          </a:p>
+        </p:txBody>
+      </p:sp>
+      <p:sp>
+        <p:nvSpPr>
+          <p:cNvPr id="8" name="TextBox 7"/>
+          <p:cNvSpPr txBox="1"/>
+          <p:nvPr/>
+        </p:nvSpPr>
+        <p:spPr>
+          <a:xfrm>
+            <a:off x="3724181" y="4294774"/>
+            <a:ext cx="3365663" cy="200019"/>
+          </a:xfrm>
+          <a:prstGeom prst="rect">
+            <a:avLst/>
+          </a:prstGeom>
+          <a:noFill/>
+        </p:spPr>
+        <p:txBody>
+          <a:bodyPr wrap="square" lIns="0" rIns="0" tIns="0" bIns="0" anchor="ctr">
+            <a:spAutoFit/>
+          </a:bodyPr>
+          <a:lstStyle/>
+          <a:p>
+            <a:pPr algn="l"/>
+            <a:r>
+              <a:rPr sz="1274" b="0" i="0">
+                <a:solidFill>
+                  <a:srgbClr val="6B7280"/>
+                </a:solidFill>
+                <a:latin typeface="Lato"/>
+              </a:rPr>
+              <a:t>Interlocuteur RH ou HSE/QHSE pour le pilotage</a:t>
+            </a:r>
+          </a:p>
+        </p:txBody>
+      </p:sp>
+      <p:sp>
+        <p:nvSpPr>
+          <p:cNvPr id="9" name="TextBox 8"/>
+          <p:cNvSpPr txBox="1"/>
+          <p:nvPr/>
+        </p:nvSpPr>
+        <p:spPr>
+          <a:xfrm>
+            <a:off x="2616332" y="5613954"/>
+            <a:ext cx="7340019" cy="209544"/>
+          </a:xfrm>
+          <a:prstGeom prst="rect">
+            <a:avLst/>
+          </a:prstGeom>
+          <a:noFill/>
+        </p:spPr>
+        <p:txBody>
+          <a:bodyPr wrap="square" lIns="0" rIns="0" tIns="0" bIns="0" anchor="ctr">
+            <a:spAutoFit/>
+          </a:bodyPr>
+          <a:lstStyle/>
+          <a:p>
+            <a:pPr algn="ctr"/>
+            <a:r>
+              <a:rPr sz="1349" b="1" i="0">
+                <a:solidFill>
+                  <a:srgbClr val="00456D"/>
+                </a:solidFill>
+                <a:latin typeface="Lato"/>
+              </a:rPr>
+              <a:t>Prochaine étape : un échange de 30 minutes pour cadrer le diagnostic de votre démarche DUERP.</a:t>
+            </a:r>
+          </a:p>
+        </p:txBody>
+      </p:sp>
     </p:spTree>
   </p:cSld>
   <p:clrMapOvr>
@@ -3607,6 +4964,240 @@
           </a:prstGeom>
         </p:spPr>
       </p:pic>
+      <p:sp>
+        <p:nvSpPr>
+          <p:cNvPr id="3" name="TextBox 2"/>
+          <p:cNvSpPr txBox="1"/>
+          <p:nvPr/>
+        </p:nvSpPr>
+        <p:spPr>
+          <a:xfrm>
+            <a:off x="952476" y="849489"/>
+            <a:ext cx="4746456" cy="1501042"/>
+          </a:xfrm>
+          <a:prstGeom prst="rect">
+            <a:avLst/>
+          </a:prstGeom>
+          <a:noFill/>
+        </p:spPr>
+        <p:txBody>
+          <a:bodyPr wrap="square" lIns="0" rIns="0" tIns="0" bIns="0" anchor="ctr">
+            <a:spAutoFit/>
+          </a:bodyPr>
+          <a:lstStyle/>
+          <a:p>
+            <a:pPr algn="l"/>
+            <a:r>
+              <a:rPr sz="3299" b="1" i="0">
+                <a:solidFill>
+                  <a:srgbClr val="0F172A"/>
+                </a:solidFill>
+                <a:latin typeface="Lato"/>
+              </a:rPr>
+              <a:t>Le DUERP n'est pas une formalité. C'est ce qui fait baisser vos accidents.</a:t>
+            </a:r>
+          </a:p>
+        </p:txBody>
+      </p:sp>
+      <p:sp>
+        <p:nvSpPr>
+          <p:cNvPr id="4" name="TextBox 3"/>
+          <p:cNvSpPr txBox="1"/>
+          <p:nvPr/>
+        </p:nvSpPr>
+        <p:spPr>
+          <a:xfrm>
+            <a:off x="952476" y="2720063"/>
+            <a:ext cx="4504021" cy="750372"/>
+          </a:xfrm>
+          <a:prstGeom prst="rect">
+            <a:avLst/>
+          </a:prstGeom>
+          <a:noFill/>
+        </p:spPr>
+        <p:txBody>
+          <a:bodyPr wrap="square" lIns="0" rIns="0" tIns="0" bIns="0" anchor="ctr">
+            <a:spAutoFit/>
+          </a:bodyPr>
+          <a:lstStyle/>
+          <a:p>
+            <a:pPr algn="l"/>
+            <a:r>
+              <a:rPr sz="1274" b="0" i="0">
+                <a:solidFill>
+                  <a:srgbClr val="6B7280"/>
+                </a:solidFill>
+                <a:latin typeface="Lato"/>
+              </a:rPr>
+              <a:t>La plupart des organisations remplissent le DUERP pour cocher l'obligation, puis le classent. Pourtant, c'est le seul document qui transforme vos risques en prévention concrète.</a:t>
+            </a:r>
+          </a:p>
+        </p:txBody>
+      </p:sp>
+      <p:sp>
+        <p:nvSpPr>
+          <p:cNvPr id="5" name="TextBox 4"/>
+          <p:cNvSpPr txBox="1"/>
+          <p:nvPr/>
+        </p:nvSpPr>
+        <p:spPr>
+          <a:xfrm>
+            <a:off x="952476" y="3755137"/>
+            <a:ext cx="4830244" cy="475196"/>
+          </a:xfrm>
+          <a:prstGeom prst="rect">
+            <a:avLst/>
+          </a:prstGeom>
+          <a:noFill/>
+        </p:spPr>
+        <p:txBody>
+          <a:bodyPr wrap="square" lIns="0" rIns="0" tIns="0" bIns="0" anchor="ctr">
+            <a:spAutoFit/>
+          </a:bodyPr>
+          <a:lstStyle/>
+          <a:p>
+            <a:pPr algn="l"/>
+            <a:r>
+              <a:rPr sz="1274" b="0" i="0">
+                <a:solidFill>
+                  <a:srgbClr val="6B7280"/>
+                </a:solidFill>
+                <a:latin typeface="Lato"/>
+              </a:rPr>
+              <a:t>Un DUERP figé ne réduit aucun accident. Votre service de santé au travail suit vos visites médicales, mais ne fait pas vivre votre DUERP.</a:t>
+            </a:r>
+          </a:p>
+        </p:txBody>
+      </p:sp>
+      <p:sp>
+        <p:nvSpPr>
+          <p:cNvPr id="6" name="TextBox 5"/>
+          <p:cNvSpPr txBox="1"/>
+          <p:nvPr/>
+        </p:nvSpPr>
+        <p:spPr>
+          <a:xfrm>
+            <a:off x="952476" y="4524559"/>
+            <a:ext cx="4756427" cy="792341"/>
+          </a:xfrm>
+          <a:prstGeom prst="rect">
+            <a:avLst/>
+          </a:prstGeom>
+          <a:noFill/>
+        </p:spPr>
+        <p:txBody>
+          <a:bodyPr wrap="square" lIns="0" rIns="0" tIns="0" bIns="0" anchor="ctr">
+            <a:spAutoFit/>
+          </a:bodyPr>
+          <a:lstStyle/>
+          <a:p>
+            <a:pPr algn="l"/>
+            <a:r>
+              <a:rPr sz="1349" b="0" i="0">
+                <a:solidFill>
+                  <a:srgbClr val="00456D"/>
+                </a:solidFill>
+                <a:latin typeface="Lato"/>
+              </a:rPr>
+              <a:t>Chez Ayming, nous croyons qu'un DUERP ne vaut que s'il est vivant : c'est ce qui fait baisser vos accidents, pas le fait de l'avoir rempli.</a:t>
+            </a:r>
+          </a:p>
+        </p:txBody>
+      </p:sp>
+      <p:sp>
+        <p:nvSpPr>
+          <p:cNvPr id="7" name="TextBox 6"/>
+          <p:cNvSpPr txBox="1"/>
+          <p:nvPr/>
+        </p:nvSpPr>
+        <p:spPr>
+          <a:xfrm>
+            <a:off x="8255140" y="1800179"/>
+            <a:ext cx="3145999" cy="161920"/>
+          </a:xfrm>
+          <a:prstGeom prst="rect">
+            <a:avLst/>
+          </a:prstGeom>
+          <a:noFill/>
+        </p:spPr>
+        <p:txBody>
+          <a:bodyPr wrap="square" lIns="0" rIns="0" tIns="0" bIns="0" anchor="ctr">
+            <a:spAutoFit/>
+          </a:bodyPr>
+          <a:lstStyle/>
+          <a:p>
+            <a:pPr algn="l"/>
+            <a:r>
+              <a:rPr sz="1050" b="1" i="0">
+                <a:solidFill>
+                  <a:srgbClr val="0F172A"/>
+                </a:solidFill>
+                <a:latin typeface="Lato"/>
+              </a:rPr>
+              <a:t>15,6%</a:t>
+            </a:r>
+          </a:p>
+          <a:p>
+            <a:pPr algn="l"/>
+            <a:r>
+              <a:rPr sz="1050" b="1" i="0">
+                <a:solidFill>
+                  <a:srgbClr val="0F172A"/>
+                </a:solidFill>
+                <a:latin typeface="Lato"/>
+              </a:rPr>
+              <a:t>des établissements transmettent leur DUERP</a:t>
+            </a:r>
+          </a:p>
+        </p:txBody>
+      </p:sp>
+      <p:sp>
+        <p:nvSpPr>
+          <p:cNvPr id="8" name="TextBox 7"/>
+          <p:cNvSpPr txBox="1"/>
+          <p:nvPr/>
+        </p:nvSpPr>
+        <p:spPr>
+          <a:xfrm>
+            <a:off x="6886402" y="4409964"/>
+            <a:ext cx="1844976" cy="161920"/>
+          </a:xfrm>
+          <a:prstGeom prst="rect">
+            <a:avLst/>
+          </a:prstGeom>
+          <a:noFill/>
+        </p:spPr>
+        <p:txBody>
+          <a:bodyPr wrap="square" lIns="0" rIns="0" tIns="0" bIns="0" anchor="ctr">
+            <a:spAutoFit/>
+          </a:bodyPr>
+          <a:lstStyle/>
+          <a:p>
+            <a:pPr algn="l"/>
+            <a:r>
+              <a:rPr sz="1048" b="1" i="0">
+                <a:solidFill>
+                  <a:srgbClr val="0F172A"/>
+                </a:solidFill>
+                <a:latin typeface="Lato"/>
+              </a:rPr>
+              <a:t>40 ans</a:t>
+            </a:r>
+          </a:p>
+          <a:p>
+            <a:pPr algn="l"/>
+            <a:r>
+              <a:rPr sz="1048" b="1" i="0">
+                <a:solidFill>
+                  <a:srgbClr val="0F172A"/>
+                </a:solidFill>
+                <a:latin typeface="Lato"/>
+              </a:rPr>
+              <a:t>de conservation exigée</a:t>
+            </a:r>
+          </a:p>
+        </p:txBody>
+      </p:sp>
     </p:spTree>
   </p:cSld>
   <p:clrMapOvr>
@@ -3649,6 +5240,251 @@
           </a:prstGeom>
         </p:spPr>
       </p:pic>
+      <p:sp>
+        <p:nvSpPr>
+          <p:cNvPr id="3" name="TextBox 2"/>
+          <p:cNvSpPr txBox="1"/>
+          <p:nvPr/>
+        </p:nvSpPr>
+        <p:spPr>
+          <a:xfrm>
+            <a:off x="1942158" y="813623"/>
+            <a:ext cx="8688368" cy="998165"/>
+          </a:xfrm>
+          <a:prstGeom prst="rect">
+            <a:avLst/>
+          </a:prstGeom>
+          <a:noFill/>
+        </p:spPr>
+        <p:txBody>
+          <a:bodyPr wrap="square" lIns="0" rIns="0" tIns="0" bIns="0" anchor="ctr">
+            <a:spAutoFit/>
+          </a:bodyPr>
+          <a:lstStyle/>
+          <a:p>
+            <a:pPr algn="ctr"/>
+            <a:r>
+              <a:rPr sz="3299" b="1" i="0">
+                <a:solidFill>
+                  <a:srgbClr val="0F172A"/>
+                </a:solidFill>
+                <a:latin typeface="Lato"/>
+              </a:rPr>
+              <a:t>Comment les organisations gèrent leur DUERP aujourd'hui</a:t>
+            </a:r>
+          </a:p>
+        </p:txBody>
+      </p:sp>
+      <p:sp>
+        <p:nvSpPr>
+          <p:cNvPr id="4" name="TextBox 3"/>
+          <p:cNvSpPr txBox="1"/>
+          <p:nvPr/>
+        </p:nvSpPr>
+        <p:spPr>
+          <a:xfrm>
+            <a:off x="1560721" y="4429163"/>
+            <a:ext cx="2212274" cy="209544"/>
+          </a:xfrm>
+          <a:prstGeom prst="rect">
+            <a:avLst/>
+          </a:prstGeom>
+          <a:noFill/>
+        </p:spPr>
+        <p:txBody>
+          <a:bodyPr wrap="square" lIns="0" rIns="0" tIns="0" bIns="0" anchor="ctr">
+            <a:spAutoFit/>
+          </a:bodyPr>
+          <a:lstStyle/>
+          <a:p>
+            <a:pPr algn="ctr"/>
+            <a:r>
+              <a:rPr sz="1349" b="1" i="0">
+                <a:solidFill>
+                  <a:srgbClr val="0DA4E8"/>
+                </a:solidFill>
+                <a:latin typeface="Lato"/>
+              </a:rPr>
+              <a:t>Le DUERP figé (Word / Excel)</a:t>
+            </a:r>
+          </a:p>
+        </p:txBody>
+      </p:sp>
+      <p:sp>
+        <p:nvSpPr>
+          <p:cNvPr id="5" name="TextBox 4"/>
+          <p:cNvSpPr txBox="1"/>
+          <p:nvPr/>
+        </p:nvSpPr>
+        <p:spPr>
+          <a:xfrm>
+            <a:off x="1091180" y="4772054"/>
+            <a:ext cx="3151356" cy="588451"/>
+          </a:xfrm>
+          <a:prstGeom prst="rect">
+            <a:avLst/>
+          </a:prstGeom>
+          <a:noFill/>
+        </p:spPr>
+        <p:txBody>
+          <a:bodyPr wrap="square" lIns="0" rIns="0" tIns="0" bIns="0" anchor="ctr">
+            <a:spAutoFit/>
+          </a:bodyPr>
+          <a:lstStyle/>
+          <a:p>
+            <a:pPr algn="ctr"/>
+            <a:r>
+              <a:rPr sz="1049" b="0" i="0">
+                <a:solidFill>
+                  <a:srgbClr val="6B7280"/>
+                </a:solidFill>
+                <a:latin typeface="Lato"/>
+              </a:rPr>
+              <a:t>Rempli une fois, jamais rouvert. Le DUERP existe mais reste un document mort, déconnecté des accidents réels et sans plan d'action suivi.</a:t>
+            </a:r>
+          </a:p>
+        </p:txBody>
+      </p:sp>
+      <p:sp>
+        <p:nvSpPr>
+          <p:cNvPr id="6" name="TextBox 5"/>
+          <p:cNvSpPr txBox="1"/>
+          <p:nvPr/>
+        </p:nvSpPr>
+        <p:spPr>
+          <a:xfrm>
+            <a:off x="4890072" y="4429163"/>
+            <a:ext cx="2792392" cy="209544"/>
+          </a:xfrm>
+          <a:prstGeom prst="rect">
+            <a:avLst/>
+          </a:prstGeom>
+          <a:noFill/>
+        </p:spPr>
+        <p:txBody>
+          <a:bodyPr wrap="square" lIns="0" rIns="0" tIns="0" bIns="0" anchor="ctr">
+            <a:spAutoFit/>
+          </a:bodyPr>
+          <a:lstStyle/>
+          <a:p>
+            <a:pPr algn="ctr"/>
+            <a:r>
+              <a:rPr sz="1349" b="1" i="0">
+                <a:solidFill>
+                  <a:srgbClr val="0DA4E8"/>
+                </a:solidFill>
+                <a:latin typeface="Lato"/>
+              </a:rPr>
+              <a:t>Le logiciel de conformité déconnecté</a:t>
+            </a:r>
+          </a:p>
+        </p:txBody>
+      </p:sp>
+      <p:sp>
+        <p:nvSpPr>
+          <p:cNvPr id="7" name="TextBox 6"/>
+          <p:cNvSpPr txBox="1"/>
+          <p:nvPr/>
+        </p:nvSpPr>
+        <p:spPr>
+          <a:xfrm>
+            <a:off x="4750623" y="4772054"/>
+            <a:ext cx="3071289" cy="801717"/>
+          </a:xfrm>
+          <a:prstGeom prst="rect">
+            <a:avLst/>
+          </a:prstGeom>
+          <a:noFill/>
+        </p:spPr>
+        <p:txBody>
+          <a:bodyPr wrap="square" lIns="0" rIns="0" tIns="0" bIns="0" anchor="ctr">
+            <a:spAutoFit/>
+          </a:bodyPr>
+          <a:lstStyle/>
+          <a:p>
+            <a:pPr algn="ctr"/>
+            <a:r>
+              <a:rPr sz="1049" b="0" i="0">
+                <a:solidFill>
+                  <a:srgbClr val="6B7280"/>
+                </a:solidFill>
+                <a:latin typeface="Lato"/>
+              </a:rPr>
+              <a:t>Un outil, pas une réduction du risque. Plateforme QHSE en self-service, qui historise et coche des cases mais ignore vos accidents réels et n'agit pas à votre place.</a:t>
+            </a:r>
+          </a:p>
+        </p:txBody>
+      </p:sp>
+      <p:sp>
+        <p:nvSpPr>
+          <p:cNvPr id="8" name="TextBox 7"/>
+          <p:cNvSpPr txBox="1"/>
+          <p:nvPr/>
+        </p:nvSpPr>
+        <p:spPr>
+          <a:xfrm>
+            <a:off x="9160737" y="4429163"/>
+            <a:ext cx="1490029" cy="209544"/>
+          </a:xfrm>
+          <a:prstGeom prst="rect">
+            <a:avLst/>
+          </a:prstGeom>
+          <a:noFill/>
+        </p:spPr>
+        <p:txBody>
+          <a:bodyPr wrap="square" lIns="0" rIns="0" tIns="0" bIns="0" anchor="ctr">
+            <a:spAutoFit/>
+          </a:bodyPr>
+          <a:lstStyle/>
+          <a:p>
+            <a:pPr algn="ctr"/>
+            <a:r>
+              <a:rPr sz="1349" b="1" i="0">
+                <a:solidFill>
+                  <a:srgbClr val="0DA4E8"/>
+                </a:solidFill>
+                <a:latin typeface="Lato"/>
+              </a:rPr>
+              <a:t>Le cabinet ponctuel</a:t>
+            </a:r>
+          </a:p>
+        </p:txBody>
+      </p:sp>
+      <p:sp>
+        <p:nvSpPr>
+          <p:cNvPr id="9" name="TextBox 8"/>
+          <p:cNvSpPr txBox="1"/>
+          <p:nvPr/>
+        </p:nvSpPr>
+        <p:spPr>
+          <a:xfrm>
+            <a:off x="8383725" y="4772054"/>
+            <a:ext cx="3044054" cy="588451"/>
+          </a:xfrm>
+          <a:prstGeom prst="rect">
+            <a:avLst/>
+          </a:prstGeom>
+          <a:noFill/>
+        </p:spPr>
+        <p:txBody>
+          <a:bodyPr wrap="square" lIns="0" rIns="0" tIns="0" bIns="0" anchor="ctr">
+            <a:spAutoFit/>
+          </a:bodyPr>
+          <a:lstStyle/>
+          <a:p>
+            <a:pPr algn="ctr"/>
+            <a:r>
+              <a:rPr sz="1049" b="0" i="0">
+                <a:solidFill>
+                  <a:srgbClr val="6B7280"/>
+                </a:solidFill>
+                <a:latin typeface="Lato"/>
+              </a:rPr>
+              <a:t>Un livrable, puis le silence. Un consultant révise le DUERP une fois. Le document est propre le jour de la remise, figé six mois plus tard.</a:t>
+            </a:r>
+          </a:p>
+        </p:txBody>
+      </p:sp>
     </p:spTree>
   </p:cSld>
   <p:clrMapOvr>
@@ -3691,6 +5527,321 @@
           </a:prstGeom>
         </p:spPr>
       </p:pic>
+      <p:sp>
+        <p:nvSpPr>
+          <p:cNvPr id="3" name="TextBox 2"/>
+          <p:cNvSpPr txBox="1"/>
+          <p:nvPr/>
+        </p:nvSpPr>
+        <p:spPr>
+          <a:xfrm>
+            <a:off x="959173" y="1152496"/>
+            <a:ext cx="10654190" cy="998165"/>
+          </a:xfrm>
+          <a:prstGeom prst="rect">
+            <a:avLst/>
+          </a:prstGeom>
+          <a:noFill/>
+        </p:spPr>
+        <p:txBody>
+          <a:bodyPr wrap="square" lIns="0" rIns="0" tIns="0" bIns="0" anchor="ctr">
+            <a:spAutoFit/>
+          </a:bodyPr>
+          <a:lstStyle/>
+          <a:p>
+            <a:pPr algn="ctr"/>
+            <a:r>
+              <a:rPr sz="3299" b="1" i="0">
+                <a:solidFill>
+                  <a:srgbClr val="0F172A"/>
+                </a:solidFill>
+                <a:latin typeface="Lato"/>
+              </a:rPr>
+              <a:t>Dans un monde idéal, voici ce que serait le pilotage de vos risques professionnels</a:t>
+            </a:r>
+          </a:p>
+        </p:txBody>
+      </p:sp>
+      <p:sp>
+        <p:nvSpPr>
+          <p:cNvPr id="4" name="TextBox 3"/>
+          <p:cNvSpPr txBox="1"/>
+          <p:nvPr/>
+        </p:nvSpPr>
+        <p:spPr>
+          <a:xfrm>
+            <a:off x="1356534" y="4387045"/>
+            <a:ext cx="1644509" cy="171445"/>
+          </a:xfrm>
+          <a:prstGeom prst="rect">
+            <a:avLst/>
+          </a:prstGeom>
+          <a:noFill/>
+        </p:spPr>
+        <p:txBody>
+          <a:bodyPr wrap="square" lIns="0" rIns="0" tIns="0" bIns="0" anchor="ctr">
+            <a:spAutoFit/>
+          </a:bodyPr>
+          <a:lstStyle/>
+          <a:p>
+            <a:pPr algn="ctr"/>
+            <a:r>
+              <a:rPr sz="1122" b="1" i="0">
+                <a:solidFill>
+                  <a:srgbClr val="0DA4E8"/>
+                </a:solidFill>
+                <a:latin typeface="Lato"/>
+              </a:rPr>
+              <a:t>Un DUERP toujours à jour</a:t>
+            </a:r>
+          </a:p>
+        </p:txBody>
+      </p:sp>
+      <p:sp>
+        <p:nvSpPr>
+          <p:cNvPr id="5" name="TextBox 4"/>
+          <p:cNvSpPr txBox="1"/>
+          <p:nvPr/>
+        </p:nvSpPr>
+        <p:spPr>
+          <a:xfrm>
+            <a:off x="963489" y="4691838"/>
+            <a:ext cx="2430451" cy="350481"/>
+          </a:xfrm>
+          <a:prstGeom prst="rect">
+            <a:avLst/>
+          </a:prstGeom>
+          <a:noFill/>
+        </p:spPr>
+        <p:txBody>
+          <a:bodyPr wrap="square" lIns="0" rIns="0" tIns="0" bIns="0" anchor="ctr">
+            <a:spAutoFit/>
+          </a:bodyPr>
+          <a:lstStyle/>
+          <a:p>
+            <a:pPr algn="ctr"/>
+            <a:r>
+              <a:rPr sz="973" b="0" i="0">
+                <a:solidFill>
+                  <a:srgbClr val="6B7280"/>
+                </a:solidFill>
+                <a:latin typeface="Lato"/>
+              </a:rPr>
+              <a:t>L'évaluation reflète la réalité du terrain en continu, pas une photo annuelle vite périmée.</a:t>
+            </a:r>
+          </a:p>
+        </p:txBody>
+      </p:sp>
+      <p:sp>
+        <p:nvSpPr>
+          <p:cNvPr id="6" name="TextBox 5"/>
+          <p:cNvSpPr txBox="1"/>
+          <p:nvPr/>
+        </p:nvSpPr>
+        <p:spPr>
+          <a:xfrm>
+            <a:off x="4118417" y="4387045"/>
+            <a:ext cx="1597332" cy="171445"/>
+          </a:xfrm>
+          <a:prstGeom prst="rect">
+            <a:avLst/>
+          </a:prstGeom>
+          <a:noFill/>
+        </p:spPr>
+        <p:txBody>
+          <a:bodyPr wrap="square" lIns="0" rIns="0" tIns="0" bIns="0" anchor="ctr">
+            <a:spAutoFit/>
+          </a:bodyPr>
+          <a:lstStyle/>
+          <a:p>
+            <a:pPr algn="ctr"/>
+            <a:r>
+              <a:rPr sz="1122" b="1" i="0">
+                <a:solidFill>
+                  <a:srgbClr val="0DA4E8"/>
+                </a:solidFill>
+                <a:latin typeface="Lato"/>
+              </a:rPr>
+              <a:t>Connecté à vos accidents</a:t>
+            </a:r>
+          </a:p>
+        </p:txBody>
+      </p:sp>
+      <p:sp>
+        <p:nvSpPr>
+          <p:cNvPr id="7" name="TextBox 6"/>
+          <p:cNvSpPr txBox="1"/>
+          <p:nvPr/>
+        </p:nvSpPr>
+        <p:spPr>
+          <a:xfrm>
+            <a:off x="3833716" y="4691838"/>
+            <a:ext cx="2166883" cy="548566"/>
+          </a:xfrm>
+          <a:prstGeom prst="rect">
+            <a:avLst/>
+          </a:prstGeom>
+          <a:noFill/>
+        </p:spPr>
+        <p:txBody>
+          <a:bodyPr wrap="square" lIns="0" rIns="0" tIns="0" bIns="0" anchor="ctr">
+            <a:spAutoFit/>
+          </a:bodyPr>
+          <a:lstStyle/>
+          <a:p>
+            <a:pPr algn="ctr"/>
+            <a:r>
+              <a:rPr sz="973" b="0" i="0">
+                <a:solidFill>
+                  <a:srgbClr val="6B7280"/>
+                </a:solidFill>
+                <a:latin typeface="Lato"/>
+              </a:rPr>
+              <a:t>Les risques qui causent vraiment vos accidents sont identifiés et priorisés, pas noyés dans une liste générique.</a:t>
+            </a:r>
+          </a:p>
+        </p:txBody>
+      </p:sp>
+      <p:sp>
+        <p:nvSpPr>
+          <p:cNvPr id="8" name="TextBox 7"/>
+          <p:cNvSpPr txBox="1"/>
+          <p:nvPr/>
+        </p:nvSpPr>
+        <p:spPr>
+          <a:xfrm>
+            <a:off x="6789666" y="4387045"/>
+            <a:ext cx="1731571" cy="171445"/>
+          </a:xfrm>
+          <a:prstGeom prst="rect">
+            <a:avLst/>
+          </a:prstGeom>
+          <a:noFill/>
+        </p:spPr>
+        <p:txBody>
+          <a:bodyPr wrap="square" lIns="0" rIns="0" tIns="0" bIns="0" anchor="ctr">
+            <a:spAutoFit/>
+          </a:bodyPr>
+          <a:lstStyle/>
+          <a:p>
+            <a:pPr algn="ctr"/>
+            <a:r>
+              <a:rPr sz="1122" b="1" i="0">
+                <a:solidFill>
+                  <a:srgbClr val="0DA4E8"/>
+                </a:solidFill>
+                <a:latin typeface="Lato"/>
+              </a:rPr>
+              <a:t>Un plan d'action qui avance</a:t>
+            </a:r>
+          </a:p>
+        </p:txBody>
+      </p:sp>
+      <p:sp>
+        <p:nvSpPr>
+          <p:cNvPr id="9" name="TextBox 8"/>
+          <p:cNvSpPr txBox="1"/>
+          <p:nvPr/>
+        </p:nvSpPr>
+        <p:spPr>
+          <a:xfrm>
+            <a:off x="6546636" y="4691838"/>
+            <a:ext cx="2217781" cy="548566"/>
+          </a:xfrm>
+          <a:prstGeom prst="rect">
+            <a:avLst/>
+          </a:prstGeom>
+          <a:noFill/>
+        </p:spPr>
+        <p:txBody>
+          <a:bodyPr wrap="square" lIns="0" rIns="0" tIns="0" bIns="0" anchor="ctr">
+            <a:spAutoFit/>
+          </a:bodyPr>
+          <a:lstStyle/>
+          <a:p>
+            <a:pPr algn="ctr"/>
+            <a:r>
+              <a:rPr sz="973" b="0" i="0">
+                <a:solidFill>
+                  <a:srgbClr val="6B7280"/>
+                </a:solidFill>
+                <a:latin typeface="Lato"/>
+              </a:rPr>
+              <a:t>Les actions de prévention sont priorisées, suivies et tenues, pas oubliées dans un classeur.</a:t>
+            </a:r>
+          </a:p>
+        </p:txBody>
+      </p:sp>
+      <p:sp>
+        <p:nvSpPr>
+          <p:cNvPr id="10" name="TextBox 9"/>
+          <p:cNvSpPr txBox="1"/>
+          <p:nvPr/>
+        </p:nvSpPr>
+        <p:spPr>
+          <a:xfrm>
+            <a:off x="9583398" y="4387045"/>
+            <a:ext cx="1620995" cy="171445"/>
+          </a:xfrm>
+          <a:prstGeom prst="rect">
+            <a:avLst/>
+          </a:prstGeom>
+          <a:noFill/>
+        </p:spPr>
+        <p:txBody>
+          <a:bodyPr wrap="square" lIns="0" rIns="0" tIns="0" bIns="0" anchor="ctr">
+            <a:spAutoFit/>
+          </a:bodyPr>
+          <a:lstStyle/>
+          <a:p>
+            <a:pPr algn="ctr"/>
+            <a:r>
+              <a:rPr sz="1122" b="1" i="0">
+                <a:solidFill>
+                  <a:srgbClr val="0DA4E8"/>
+                </a:solidFill>
+                <a:latin typeface="Lato"/>
+              </a:rPr>
+              <a:t>Une sinistralité qui baisse</a:t>
+            </a:r>
+          </a:p>
+        </p:txBody>
+      </p:sp>
+      <p:sp>
+        <p:nvSpPr>
+          <p:cNvPr id="11" name="TextBox 10"/>
+          <p:cNvSpPr txBox="1"/>
+          <p:nvPr/>
+        </p:nvSpPr>
+        <p:spPr>
+          <a:xfrm>
+            <a:off x="9227261" y="4691838"/>
+            <a:ext cx="2333120" cy="548566"/>
+          </a:xfrm>
+          <a:prstGeom prst="rect">
+            <a:avLst/>
+          </a:prstGeom>
+          <a:noFill/>
+        </p:spPr>
+        <p:txBody>
+          <a:bodyPr wrap="square" lIns="0" rIns="0" tIns="0" bIns="0" anchor="ctr">
+            <a:spAutoFit/>
+          </a:bodyPr>
+          <a:lstStyle/>
+          <a:p>
+            <a:pPr algn="ctr"/>
+            <a:r>
+              <a:rPr sz="973" b="0" i="0">
+                <a:solidFill>
+                  <a:srgbClr val="6B7280"/>
+                </a:solidFill>
+                <a:latin typeface="Lato"/>
+              </a:rPr>
+              <a:t>Moins d'accidents, un coût AT/MP qui se maîtrise, une prévention qui se voit dans les chiffres.</a:t>
+            </a:r>
+          </a:p>
+        </p:txBody>
+      </p:sp>
     </p:spTree>
   </p:cSld>
   <p:clrMapOvr>
@@ -3733,6 +5884,356 @@
           </a:prstGeom>
         </p:spPr>
       </p:pic>
+      <p:sp>
+        <p:nvSpPr>
+          <p:cNvPr id="3" name="TextBox 2"/>
+          <p:cNvSpPr txBox="1"/>
+          <p:nvPr/>
+        </p:nvSpPr>
+        <p:spPr>
+          <a:xfrm>
+            <a:off x="4313824" y="1982192"/>
+            <a:ext cx="3944888" cy="952476"/>
+          </a:xfrm>
+          <a:prstGeom prst="rect">
+            <a:avLst/>
+          </a:prstGeom>
+          <a:noFill/>
+        </p:spPr>
+        <p:txBody>
+          <a:bodyPr wrap="square" lIns="0" rIns="0" tIns="0" bIns="0" anchor="ctr">
+            <a:spAutoFit/>
+          </a:bodyPr>
+          <a:lstStyle/>
+          <a:p>
+            <a:pPr algn="ctr"/>
+            <a:r>
+              <a:rPr sz="3149" b="1" i="0">
+                <a:solidFill>
+                  <a:srgbClr val="0F172A"/>
+                </a:solidFill>
+                <a:latin typeface="Lato"/>
+              </a:rPr>
+              <a:t>Piloter le DUERP et les risques professionnels</a:t>
+            </a:r>
+          </a:p>
+        </p:txBody>
+      </p:sp>
+      <p:sp>
+        <p:nvSpPr>
+          <p:cNvPr id="4" name="TextBox 3"/>
+          <p:cNvSpPr txBox="1"/>
+          <p:nvPr/>
+        </p:nvSpPr>
+        <p:spPr>
+          <a:xfrm>
+            <a:off x="1785595" y="3601401"/>
+            <a:ext cx="1146692" cy="542911"/>
+          </a:xfrm>
+          <a:prstGeom prst="rect">
+            <a:avLst/>
+          </a:prstGeom>
+          <a:noFill/>
+        </p:spPr>
+        <p:txBody>
+          <a:bodyPr wrap="square" lIns="0" rIns="0" tIns="0" bIns="0" anchor="ctr">
+            <a:spAutoFit/>
+          </a:bodyPr>
+          <a:lstStyle/>
+          <a:p>
+            <a:pPr algn="ctr"/>
+            <a:r>
+              <a:rPr sz="3599" b="1" i="0">
+                <a:solidFill>
+                  <a:srgbClr val="0DA4E8"/>
+                </a:solidFill>
+                <a:latin typeface="Lato"/>
+              </a:rPr>
+              <a:t>4,5 M</a:t>
+            </a:r>
+          </a:p>
+        </p:txBody>
+      </p:sp>
+      <p:sp>
+        <p:nvSpPr>
+          <p:cNvPr id="5" name="TextBox 4"/>
+          <p:cNvSpPr txBox="1"/>
+          <p:nvPr/>
+        </p:nvSpPr>
+        <p:spPr>
+          <a:xfrm>
+            <a:off x="1654332" y="4182412"/>
+            <a:ext cx="1409367" cy="142871"/>
+          </a:xfrm>
+          <a:prstGeom prst="rect">
+            <a:avLst/>
+          </a:prstGeom>
+          <a:noFill/>
+        </p:spPr>
+        <p:txBody>
+          <a:bodyPr wrap="square" lIns="0" rIns="0" tIns="0" bIns="0" anchor="ctr">
+            <a:spAutoFit/>
+          </a:bodyPr>
+          <a:lstStyle/>
+          <a:p>
+            <a:pPr algn="ctr"/>
+            <a:r>
+              <a:rPr sz="899" b="1" i="0">
+                <a:solidFill>
+                  <a:srgbClr val="6B7280"/>
+                </a:solidFill>
+                <a:latin typeface="Lato"/>
+              </a:rPr>
+              <a:t>DE SALARIÉS COUVERTS</a:t>
+            </a:r>
+          </a:p>
+        </p:txBody>
+      </p:sp>
+      <p:sp>
+        <p:nvSpPr>
+          <p:cNvPr id="6" name="TextBox 5"/>
+          <p:cNvSpPr txBox="1"/>
+          <p:nvPr/>
+        </p:nvSpPr>
+        <p:spPr>
+          <a:xfrm>
+            <a:off x="4591828" y="3601401"/>
+            <a:ext cx="1060820" cy="542911"/>
+          </a:xfrm>
+          <a:prstGeom prst="rect">
+            <a:avLst/>
+          </a:prstGeom>
+          <a:noFill/>
+        </p:spPr>
+        <p:txBody>
+          <a:bodyPr wrap="square" lIns="0" rIns="0" tIns="0" bIns="0" anchor="ctr">
+            <a:spAutoFit/>
+          </a:bodyPr>
+          <a:lstStyle/>
+          <a:p>
+            <a:pPr algn="ctr"/>
+            <a:r>
+              <a:rPr sz="3606" b="1" i="0">
+                <a:solidFill>
+                  <a:srgbClr val="0DA4E8"/>
+                </a:solidFill>
+                <a:latin typeface="Lato"/>
+              </a:rPr>
+              <a:t>330+</a:t>
+            </a:r>
+          </a:p>
+        </p:txBody>
+      </p:sp>
+      <p:sp>
+        <p:nvSpPr>
+          <p:cNvPr id="7" name="TextBox 6"/>
+          <p:cNvSpPr txBox="1"/>
+          <p:nvPr/>
+        </p:nvSpPr>
+        <p:spPr>
+          <a:xfrm>
+            <a:off x="4406690" y="4182412"/>
+            <a:ext cx="1431244" cy="142871"/>
+          </a:xfrm>
+          <a:prstGeom prst="rect">
+            <a:avLst/>
+          </a:prstGeom>
+          <a:noFill/>
+        </p:spPr>
+        <p:txBody>
+          <a:bodyPr wrap="square" lIns="0" rIns="0" tIns="0" bIns="0" anchor="ctr">
+            <a:spAutoFit/>
+          </a:bodyPr>
+          <a:lstStyle/>
+          <a:p>
+            <a:pPr algn="ctr"/>
+            <a:r>
+              <a:rPr sz="901" b="1" i="0">
+                <a:solidFill>
+                  <a:srgbClr val="6B7280"/>
+                </a:solidFill>
+                <a:latin typeface="Lato"/>
+              </a:rPr>
+              <a:t>CLIENTS ACCOMPAGNÉS</a:t>
+            </a:r>
+          </a:p>
+        </p:txBody>
+      </p:sp>
+      <p:sp>
+        <p:nvSpPr>
+          <p:cNvPr id="8" name="TextBox 7"/>
+          <p:cNvSpPr txBox="1"/>
+          <p:nvPr/>
+        </p:nvSpPr>
+        <p:spPr>
+          <a:xfrm>
+            <a:off x="7290609" y="3601401"/>
+            <a:ext cx="795615" cy="542911"/>
+          </a:xfrm>
+          <a:prstGeom prst="rect">
+            <a:avLst/>
+          </a:prstGeom>
+          <a:noFill/>
+        </p:spPr>
+        <p:txBody>
+          <a:bodyPr wrap="square" lIns="0" rIns="0" tIns="0" bIns="0" anchor="ctr">
+            <a:spAutoFit/>
+          </a:bodyPr>
+          <a:lstStyle/>
+          <a:p>
+            <a:pPr algn="ctr"/>
+            <a:r>
+              <a:rPr sz="3585" b="1" i="0">
+                <a:solidFill>
+                  <a:srgbClr val="0DA4E8"/>
+                </a:solidFill>
+                <a:latin typeface="Lato"/>
+              </a:rPr>
+              <a:t>35+</a:t>
+            </a:r>
+          </a:p>
+        </p:txBody>
+      </p:sp>
+      <p:sp>
+        <p:nvSpPr>
+          <p:cNvPr id="9" name="TextBox 8"/>
+          <p:cNvSpPr txBox="1"/>
+          <p:nvPr/>
+        </p:nvSpPr>
+        <p:spPr>
+          <a:xfrm>
+            <a:off x="7180926" y="4182412"/>
+            <a:ext cx="1014982" cy="142871"/>
+          </a:xfrm>
+          <a:prstGeom prst="rect">
+            <a:avLst/>
+          </a:prstGeom>
+          <a:noFill/>
+        </p:spPr>
+        <p:txBody>
+          <a:bodyPr wrap="square" lIns="0" rIns="0" tIns="0" bIns="0" anchor="ctr">
+            <a:spAutoFit/>
+          </a:bodyPr>
+          <a:lstStyle/>
+          <a:p>
+            <a:pPr algn="ctr"/>
+            <a:r>
+              <a:rPr sz="896" b="1" i="0">
+                <a:solidFill>
+                  <a:srgbClr val="6B7280"/>
+                </a:solidFill>
+                <a:latin typeface="Lato"/>
+              </a:rPr>
+              <a:t>ANS D'EXPERTISE</a:t>
+            </a:r>
+          </a:p>
+        </p:txBody>
+      </p:sp>
+      <p:sp>
+        <p:nvSpPr>
+          <p:cNvPr id="10" name="TextBox 9"/>
+          <p:cNvSpPr txBox="1"/>
+          <p:nvPr/>
+        </p:nvSpPr>
+        <p:spPr>
+          <a:xfrm>
+            <a:off x="9779846" y="3601401"/>
+            <a:ext cx="897559" cy="542911"/>
+          </a:xfrm>
+          <a:prstGeom prst="rect">
+            <a:avLst/>
+          </a:prstGeom>
+          <a:noFill/>
+        </p:spPr>
+        <p:txBody>
+          <a:bodyPr wrap="square" lIns="0" rIns="0" tIns="0" bIns="0" anchor="ctr">
+            <a:spAutoFit/>
+          </a:bodyPr>
+          <a:lstStyle/>
+          <a:p>
+            <a:pPr algn="ctr"/>
+            <a:r>
+              <a:rPr sz="3595" b="1" i="0">
+                <a:solidFill>
+                  <a:srgbClr val="0DA4E8"/>
+                </a:solidFill>
+                <a:latin typeface="Lato"/>
+              </a:rPr>
+              <a:t>89%</a:t>
+            </a:r>
+          </a:p>
+        </p:txBody>
+      </p:sp>
+      <p:sp>
+        <p:nvSpPr>
+          <p:cNvPr id="11" name="TextBox 10"/>
+          <p:cNvSpPr txBox="1"/>
+          <p:nvPr/>
+        </p:nvSpPr>
+        <p:spPr>
+          <a:xfrm>
+            <a:off x="9538900" y="4182412"/>
+            <a:ext cx="1379453" cy="142871"/>
+          </a:xfrm>
+          <a:prstGeom prst="rect">
+            <a:avLst/>
+          </a:prstGeom>
+          <a:noFill/>
+        </p:spPr>
+        <p:txBody>
+          <a:bodyPr wrap="square" lIns="0" rIns="0" tIns="0" bIns="0" anchor="ctr">
+            <a:spAutoFit/>
+          </a:bodyPr>
+          <a:lstStyle/>
+          <a:p>
+            <a:pPr algn="ctr"/>
+            <a:r>
+              <a:rPr sz="898" b="1" i="0">
+                <a:solidFill>
+                  <a:srgbClr val="6B7280"/>
+                </a:solidFill>
+                <a:latin typeface="Lato"/>
+              </a:rPr>
+              <a:t>DE RECOMMANDATION</a:t>
+            </a:r>
+          </a:p>
+        </p:txBody>
+      </p:sp>
+      <p:sp>
+        <p:nvSpPr>
+          <p:cNvPr id="12" name="TextBox 11"/>
+          <p:cNvSpPr txBox="1"/>
+          <p:nvPr/>
+        </p:nvSpPr>
+        <p:spPr>
+          <a:xfrm>
+            <a:off x="1948409" y="5068215"/>
+            <a:ext cx="8675718" cy="792341"/>
+          </a:xfrm>
+          <a:prstGeom prst="rect">
+            <a:avLst/>
+          </a:prstGeom>
+          <a:noFill/>
+        </p:spPr>
+        <p:txBody>
+          <a:bodyPr wrap="square" lIns="0" rIns="0" tIns="0" bIns="0" anchor="ctr">
+            <a:spAutoFit/>
+          </a:bodyPr>
+          <a:lstStyle/>
+          <a:p>
+            <a:pPr algn="ctr"/>
+            <a:r>
+              <a:rPr sz="1349" b="0" i="0">
+                <a:solidFill>
+                  <a:srgbClr val="0F172A"/>
+                </a:solidFill>
+                <a:latin typeface="Lato"/>
+              </a:rPr>
+              <a:t>Acciline+ est le logiciel qui transforme votre DUERP en outil de pilotage vivant, alimenté par vos accidents réels, pour réduire votre sinistralité et maîtriser vos cotisations AT/MP. Le contenu du DUERP et les décisions de prévention restent de votre responsabilité.</a:t>
+            </a:r>
+          </a:p>
+        </p:txBody>
+      </p:sp>
     </p:spTree>
   </p:cSld>
   <p:clrMapOvr>
@@ -3775,6 +6276,321 @@
           </a:prstGeom>
         </p:spPr>
       </p:pic>
+      <p:sp>
+        <p:nvSpPr>
+          <p:cNvPr id="3" name="TextBox 2"/>
+          <p:cNvSpPr txBox="1"/>
+          <p:nvPr/>
+        </p:nvSpPr>
+        <p:spPr>
+          <a:xfrm>
+            <a:off x="3749481" y="1750770"/>
+            <a:ext cx="5073572" cy="495287"/>
+          </a:xfrm>
+          <a:prstGeom prst="rect">
+            <a:avLst/>
+          </a:prstGeom>
+          <a:noFill/>
+        </p:spPr>
+        <p:txBody>
+          <a:bodyPr wrap="square" lIns="0" rIns="0" tIns="0" bIns="0" anchor="ctr">
+            <a:spAutoFit/>
+          </a:bodyPr>
+          <a:lstStyle/>
+          <a:p>
+            <a:pPr algn="ctr"/>
+            <a:r>
+              <a:rPr sz="3297" b="1" i="0">
+                <a:solidFill>
+                  <a:srgbClr val="0F172A"/>
+                </a:solidFill>
+                <a:latin typeface="Lato"/>
+              </a:rPr>
+              <a:t>Ce qu'Ayming vous apporte</a:t>
+            </a:r>
+          </a:p>
+        </p:txBody>
+      </p:sp>
+      <p:sp>
+        <p:nvSpPr>
+          <p:cNvPr id="4" name="TextBox 3"/>
+          <p:cNvSpPr txBox="1"/>
+          <p:nvPr/>
+        </p:nvSpPr>
+        <p:spPr>
+          <a:xfrm>
+            <a:off x="2324041" y="2729886"/>
+            <a:ext cx="3027237" cy="209544"/>
+          </a:xfrm>
+          <a:prstGeom prst="rect">
+            <a:avLst/>
+          </a:prstGeom>
+          <a:noFill/>
+        </p:spPr>
+        <p:txBody>
+          <a:bodyPr wrap="square" lIns="0" rIns="0" tIns="0" bIns="0" anchor="ctr">
+            <a:spAutoFit/>
+          </a:bodyPr>
+          <a:lstStyle/>
+          <a:p>
+            <a:pPr algn="l"/>
+            <a:r>
+              <a:rPr sz="1349" b="1" i="0">
+                <a:solidFill>
+                  <a:srgbClr val="0F172A"/>
+                </a:solidFill>
+                <a:latin typeface="Lato"/>
+              </a:rPr>
+              <a:t>Un DUERP vivant, pas un document figé</a:t>
+            </a:r>
+          </a:p>
+        </p:txBody>
+      </p:sp>
+      <p:sp>
+        <p:nvSpPr>
+          <p:cNvPr id="5" name="TextBox 4"/>
+          <p:cNvSpPr txBox="1"/>
+          <p:nvPr/>
+        </p:nvSpPr>
+        <p:spPr>
+          <a:xfrm>
+            <a:off x="2324041" y="3053727"/>
+            <a:ext cx="3050304" cy="375186"/>
+          </a:xfrm>
+          <a:prstGeom prst="rect">
+            <a:avLst/>
+          </a:prstGeom>
+          <a:noFill/>
+        </p:spPr>
+        <p:txBody>
+          <a:bodyPr wrap="square" lIns="0" rIns="0" tIns="0" bIns="0" anchor="ctr">
+            <a:spAutoFit/>
+          </a:bodyPr>
+          <a:lstStyle/>
+          <a:p>
+            <a:pPr algn="l"/>
+            <a:r>
+              <a:rPr sz="1049" b="0" i="0">
+                <a:solidFill>
+                  <a:srgbClr val="6B7280"/>
+                </a:solidFill>
+                <a:latin typeface="Lato"/>
+              </a:rPr>
+              <a:t>Une évaluation tenue à jour en continu, structurée et exploitable.</a:t>
+            </a:r>
+          </a:p>
+        </p:txBody>
+      </p:sp>
+      <p:sp>
+        <p:nvSpPr>
+          <p:cNvPr id="6" name="TextBox 5"/>
+          <p:cNvSpPr txBox="1"/>
+          <p:nvPr/>
+        </p:nvSpPr>
+        <p:spPr>
+          <a:xfrm>
+            <a:off x="7467413" y="2729886"/>
+            <a:ext cx="2324488" cy="209544"/>
+          </a:xfrm>
+          <a:prstGeom prst="rect">
+            <a:avLst/>
+          </a:prstGeom>
+          <a:noFill/>
+        </p:spPr>
+        <p:txBody>
+          <a:bodyPr wrap="square" lIns="0" rIns="0" tIns="0" bIns="0" anchor="ctr">
+            <a:spAutoFit/>
+          </a:bodyPr>
+          <a:lstStyle/>
+          <a:p>
+            <a:pPr algn="l"/>
+            <a:r>
+              <a:rPr sz="1349" b="1" i="0">
+                <a:solidFill>
+                  <a:srgbClr val="0F172A"/>
+                </a:solidFill>
+                <a:latin typeface="Lato"/>
+              </a:rPr>
+              <a:t>Connecté à vos accidents réels</a:t>
+            </a:r>
+          </a:p>
+        </p:txBody>
+      </p:sp>
+      <p:sp>
+        <p:nvSpPr>
+          <p:cNvPr id="7" name="TextBox 6"/>
+          <p:cNvSpPr txBox="1"/>
+          <p:nvPr/>
+        </p:nvSpPr>
+        <p:spPr>
+          <a:xfrm>
+            <a:off x="7467413" y="3053727"/>
+            <a:ext cx="3492908" cy="375186"/>
+          </a:xfrm>
+          <a:prstGeom prst="rect">
+            <a:avLst/>
+          </a:prstGeom>
+          <a:noFill/>
+        </p:spPr>
+        <p:txBody>
+          <a:bodyPr wrap="square" lIns="0" rIns="0" tIns="0" bIns="0" anchor="ctr">
+            <a:spAutoFit/>
+          </a:bodyPr>
+          <a:lstStyle/>
+          <a:p>
+            <a:pPr algn="l"/>
+            <a:r>
+              <a:rPr sz="1049" b="0" i="0">
+                <a:solidFill>
+                  <a:srgbClr val="6B7280"/>
+                </a:solidFill>
+                <a:latin typeface="Lato"/>
+              </a:rPr>
+              <a:t>Une prévention pilotée par la réalité de votre sinistralité, pas par une liste générique.</a:t>
+            </a:r>
+          </a:p>
+        </p:txBody>
+      </p:sp>
+      <p:sp>
+        <p:nvSpPr>
+          <p:cNvPr id="8" name="TextBox 7"/>
+          <p:cNvSpPr txBox="1"/>
+          <p:nvPr/>
+        </p:nvSpPr>
+        <p:spPr>
+          <a:xfrm>
+            <a:off x="2324041" y="3937447"/>
+            <a:ext cx="3323546" cy="209544"/>
+          </a:xfrm>
+          <a:prstGeom prst="rect">
+            <a:avLst/>
+          </a:prstGeom>
+          <a:noFill/>
+        </p:spPr>
+        <p:txBody>
+          <a:bodyPr wrap="square" lIns="0" rIns="0" tIns="0" bIns="0" anchor="ctr">
+            <a:spAutoFit/>
+          </a:bodyPr>
+          <a:lstStyle/>
+          <a:p>
+            <a:pPr algn="l"/>
+            <a:r>
+              <a:rPr sz="1349" b="1" i="0">
+                <a:solidFill>
+                  <a:srgbClr val="0F172A"/>
+                </a:solidFill>
+                <a:latin typeface="Lato"/>
+              </a:rPr>
+              <a:t>Un plan d'action piloté, pas une liste oubliée</a:t>
+            </a:r>
+          </a:p>
+        </p:txBody>
+      </p:sp>
+      <p:sp>
+        <p:nvSpPr>
+          <p:cNvPr id="9" name="TextBox 8"/>
+          <p:cNvSpPr txBox="1"/>
+          <p:nvPr/>
+        </p:nvSpPr>
+        <p:spPr>
+          <a:xfrm>
+            <a:off x="2324041" y="4261289"/>
+            <a:ext cx="3158053" cy="161920"/>
+          </a:xfrm>
+          <a:prstGeom prst="rect">
+            <a:avLst/>
+          </a:prstGeom>
+          <a:noFill/>
+        </p:spPr>
+        <p:txBody>
+          <a:bodyPr wrap="square" lIns="0" rIns="0" tIns="0" bIns="0" anchor="ctr">
+            <a:spAutoFit/>
+          </a:bodyPr>
+          <a:lstStyle/>
+          <a:p>
+            <a:pPr algn="l"/>
+            <a:r>
+              <a:rPr sz="1049" b="0" i="0">
+                <a:solidFill>
+                  <a:srgbClr val="6B7280"/>
+                </a:solidFill>
+                <a:latin typeface="Lato"/>
+              </a:rPr>
+              <a:t>Des actions de prévention priorisées, suivies et tenues.</a:t>
+            </a:r>
+          </a:p>
+        </p:txBody>
+      </p:sp>
+      <p:sp>
+        <p:nvSpPr>
+          <p:cNvPr id="10" name="TextBox 9"/>
+          <p:cNvSpPr txBox="1"/>
+          <p:nvPr/>
+        </p:nvSpPr>
+        <p:spPr>
+          <a:xfrm>
+            <a:off x="7467413" y="3937447"/>
+            <a:ext cx="3020986" cy="209544"/>
+          </a:xfrm>
+          <a:prstGeom prst="rect">
+            <a:avLst/>
+          </a:prstGeom>
+          <a:noFill/>
+        </p:spPr>
+        <p:txBody>
+          <a:bodyPr wrap="square" lIns="0" rIns="0" tIns="0" bIns="0" anchor="ctr">
+            <a:spAutoFit/>
+          </a:bodyPr>
+          <a:lstStyle/>
+          <a:p>
+            <a:pPr algn="l"/>
+            <a:r>
+              <a:rPr sz="1349" b="1" i="0">
+                <a:solidFill>
+                  <a:srgbClr val="0F172A"/>
+                </a:solidFill>
+                <a:latin typeface="Lato"/>
+              </a:rPr>
+              <a:t>Une prévention qui réduit vos accidents</a:t>
+            </a:r>
+          </a:p>
+        </p:txBody>
+      </p:sp>
+      <p:sp>
+        <p:nvSpPr>
+          <p:cNvPr id="11" name="TextBox 10"/>
+          <p:cNvSpPr txBox="1"/>
+          <p:nvPr/>
+        </p:nvSpPr>
+        <p:spPr>
+          <a:xfrm>
+            <a:off x="7467413" y="4261289"/>
+            <a:ext cx="3344530" cy="375186"/>
+          </a:xfrm>
+          <a:prstGeom prst="rect">
+            <a:avLst/>
+          </a:prstGeom>
+          <a:noFill/>
+        </p:spPr>
+        <p:txBody>
+          <a:bodyPr wrap="square" lIns="0" rIns="0" tIns="0" bIns="0" anchor="ctr">
+            <a:spAutoFit/>
+          </a:bodyPr>
+          <a:lstStyle/>
+          <a:p>
+            <a:pPr algn="l"/>
+            <a:r>
+              <a:rPr sz="1049" b="0" i="0">
+                <a:solidFill>
+                  <a:srgbClr val="6B7280"/>
+                </a:solidFill>
+                <a:latin typeface="Lato"/>
+              </a:rPr>
+              <a:t>Cibler les risques qui causent vos accidents et réduire leur fréquence.</a:t>
+            </a:r>
+          </a:p>
+        </p:txBody>
+      </p:sp>
     </p:spTree>
   </p:cSld>
   <p:clrMapOvr>
@@ -3817,6 +6633,181 @@
           </a:prstGeom>
         </p:spPr>
       </p:pic>
+      <p:sp>
+        <p:nvSpPr>
+          <p:cNvPr id="3" name="TextBox 2"/>
+          <p:cNvSpPr txBox="1"/>
+          <p:nvPr/>
+        </p:nvSpPr>
+        <p:spPr>
+          <a:xfrm>
+            <a:off x="952476" y="1475445"/>
+            <a:ext cx="4018110" cy="872408"/>
+          </a:xfrm>
+          <a:prstGeom prst="rect">
+            <a:avLst/>
+          </a:prstGeom>
+          <a:noFill/>
+        </p:spPr>
+        <p:txBody>
+          <a:bodyPr wrap="square" lIns="0" rIns="0" tIns="0" bIns="0" anchor="ctr">
+            <a:spAutoFit/>
+          </a:bodyPr>
+          <a:lstStyle/>
+          <a:p>
+            <a:pPr algn="l"/>
+            <a:r>
+              <a:rPr sz="2849" b="1" i="0">
+                <a:solidFill>
+                  <a:srgbClr val="0F172A"/>
+                </a:solidFill>
+                <a:latin typeface="Lato"/>
+              </a:rPr>
+              <a:t>Un DUERP vivant, pas un document figé</a:t>
+            </a:r>
+          </a:p>
+        </p:txBody>
+      </p:sp>
+      <p:sp>
+        <p:nvSpPr>
+          <p:cNvPr id="4" name="TextBox 3"/>
+          <p:cNvSpPr txBox="1"/>
+          <p:nvPr/>
+        </p:nvSpPr>
+        <p:spPr>
+          <a:xfrm>
+            <a:off x="1352516" y="2658301"/>
+            <a:ext cx="4113655" cy="442901"/>
+          </a:xfrm>
+          <a:prstGeom prst="rect">
+            <a:avLst/>
+          </a:prstGeom>
+          <a:noFill/>
+        </p:spPr>
+        <p:txBody>
+          <a:bodyPr wrap="square" lIns="0" rIns="0" tIns="0" bIns="0" anchor="ctr">
+            <a:spAutoFit/>
+          </a:bodyPr>
+          <a:lstStyle/>
+          <a:p>
+            <a:pPr algn="l"/>
+            <a:r>
+              <a:rPr sz="1274" b="0" i="0">
+                <a:solidFill>
+                  <a:srgbClr val="0F172A"/>
+                </a:solidFill>
+                <a:latin typeface="Lato"/>
+              </a:rPr>
+              <a:t>Évaluation structurée par unité de travail, cotée en gravité, fréquence et maîtrise</a:t>
+            </a:r>
+          </a:p>
+        </p:txBody>
+      </p:sp>
+      <p:sp>
+        <p:nvSpPr>
+          <p:cNvPr id="5" name="TextBox 4"/>
+          <p:cNvSpPr txBox="1"/>
+          <p:nvPr/>
+        </p:nvSpPr>
+        <p:spPr>
+          <a:xfrm>
+            <a:off x="1352516" y="3334559"/>
+            <a:ext cx="4481549" cy="442901"/>
+          </a:xfrm>
+          <a:prstGeom prst="rect">
+            <a:avLst/>
+          </a:prstGeom>
+          <a:noFill/>
+        </p:spPr>
+        <p:txBody>
+          <a:bodyPr wrap="square" lIns="0" rIns="0" tIns="0" bIns="0" anchor="ctr">
+            <a:spAutoFit/>
+          </a:bodyPr>
+          <a:lstStyle/>
+          <a:p>
+            <a:pPr algn="l"/>
+            <a:r>
+              <a:rPr sz="1274" b="0" i="0">
+                <a:solidFill>
+                  <a:srgbClr val="0F172A"/>
+                </a:solidFill>
+                <a:latin typeface="Lato"/>
+              </a:rPr>
+              <a:t>Chaque risque relié à ses équipements de protection (EPI) et ses fiches de sécurité</a:t>
+            </a:r>
+          </a:p>
+        </p:txBody>
+      </p:sp>
+      <p:sp>
+        <p:nvSpPr>
+          <p:cNvPr id="6" name="TextBox 5"/>
+          <p:cNvSpPr txBox="1"/>
+          <p:nvPr/>
+        </p:nvSpPr>
+        <p:spPr>
+          <a:xfrm>
+            <a:off x="1352516" y="4010817"/>
+            <a:ext cx="4531256" cy="200019"/>
+          </a:xfrm>
+          <a:prstGeom prst="rect">
+            <a:avLst/>
+          </a:prstGeom>
+          <a:noFill/>
+        </p:spPr>
+        <p:txBody>
+          <a:bodyPr wrap="square" lIns="0" rIns="0" tIns="0" bIns="0" anchor="ctr">
+            <a:spAutoFit/>
+          </a:bodyPr>
+          <a:lstStyle/>
+          <a:p>
+            <a:pPr algn="l"/>
+            <a:r>
+              <a:rPr sz="1274" b="0" i="0">
+                <a:solidFill>
+                  <a:srgbClr val="0F172A"/>
+                </a:solidFill>
+                <a:latin typeface="Lato"/>
+              </a:rPr>
+              <a:t>Mise à jour en continu plutôt qu'une photo annuelle vite périmée</a:t>
+            </a:r>
+          </a:p>
+        </p:txBody>
+      </p:sp>
+      <p:sp>
+        <p:nvSpPr>
+          <p:cNvPr id="7" name="TextBox 6"/>
+          <p:cNvSpPr txBox="1"/>
+          <p:nvPr/>
+        </p:nvSpPr>
+        <p:spPr>
+          <a:xfrm>
+            <a:off x="1352516" y="4468006"/>
+            <a:ext cx="3575506" cy="442901"/>
+          </a:xfrm>
+          <a:prstGeom prst="rect">
+            <a:avLst/>
+          </a:prstGeom>
+          <a:noFill/>
+        </p:spPr>
+        <p:txBody>
+          <a:bodyPr wrap="square" lIns="0" rIns="0" tIns="0" bIns="0" anchor="ctr">
+            <a:spAutoFit/>
+          </a:bodyPr>
+          <a:lstStyle/>
+          <a:p>
+            <a:pPr algn="l"/>
+            <a:r>
+              <a:rPr sz="1274" b="0" i="0">
+                <a:solidFill>
+                  <a:srgbClr val="0F172A"/>
+                </a:solidFill>
+                <a:latin typeface="Lato"/>
+              </a:rPr>
+              <a:t>Archivage et historisation des versions sur la durée réglementaire</a:t>
+            </a:r>
+          </a:p>
+        </p:txBody>
+      </p:sp>
     </p:spTree>
   </p:cSld>
   <p:clrMapOvr>
@@ -3859,6 +6850,181 @@
           </a:prstGeom>
         </p:spPr>
       </p:pic>
+      <p:sp>
+        <p:nvSpPr>
+          <p:cNvPr id="3" name="TextBox 2"/>
+          <p:cNvSpPr txBox="1"/>
+          <p:nvPr/>
+        </p:nvSpPr>
+        <p:spPr>
+          <a:xfrm>
+            <a:off x="952476" y="1692579"/>
+            <a:ext cx="4907335" cy="438139"/>
+          </a:xfrm>
+          <a:prstGeom prst="rect">
+            <a:avLst/>
+          </a:prstGeom>
+          <a:noFill/>
+        </p:spPr>
+        <p:txBody>
+          <a:bodyPr wrap="square" lIns="0" rIns="0" tIns="0" bIns="0" anchor="ctr">
+            <a:spAutoFit/>
+          </a:bodyPr>
+          <a:lstStyle/>
+          <a:p>
+            <a:pPr algn="l"/>
+            <a:r>
+              <a:rPr sz="2849" b="1" i="0">
+                <a:solidFill>
+                  <a:srgbClr val="0F172A"/>
+                </a:solidFill>
+                <a:latin typeface="Lato"/>
+              </a:rPr>
+              <a:t>Connecté à vos accidents réels</a:t>
+            </a:r>
+          </a:p>
+        </p:txBody>
+      </p:sp>
+      <p:sp>
+        <p:nvSpPr>
+          <p:cNvPr id="4" name="TextBox 3"/>
+          <p:cNvSpPr txBox="1"/>
+          <p:nvPr/>
+        </p:nvSpPr>
+        <p:spPr>
+          <a:xfrm>
+            <a:off x="1352516" y="2441166"/>
+            <a:ext cx="4447914" cy="442901"/>
+          </a:xfrm>
+          <a:prstGeom prst="rect">
+            <a:avLst/>
+          </a:prstGeom>
+          <a:noFill/>
+        </p:spPr>
+        <p:txBody>
+          <a:bodyPr wrap="square" lIns="0" rIns="0" tIns="0" bIns="0" anchor="ctr">
+            <a:spAutoFit/>
+          </a:bodyPr>
+          <a:lstStyle/>
+          <a:p>
+            <a:pPr algn="l"/>
+            <a:r>
+              <a:rPr sz="1274" b="0" i="0">
+                <a:solidFill>
+                  <a:srgbClr val="0F172A"/>
+                </a:solidFill>
+                <a:latin typeface="Lato"/>
+              </a:rPr>
+              <a:t>L'évaluation se nourrit de vos événements et remontées terrain, pas d'une liste générique</a:t>
+            </a:r>
+          </a:p>
+        </p:txBody>
+      </p:sp>
+      <p:sp>
+        <p:nvSpPr>
+          <p:cNvPr id="5" name="TextBox 4"/>
+          <p:cNvSpPr txBox="1"/>
+          <p:nvPr/>
+        </p:nvSpPr>
+        <p:spPr>
+          <a:xfrm>
+            <a:off x="1352516" y="3117424"/>
+            <a:ext cx="4423061" cy="442901"/>
+          </a:xfrm>
+          <a:prstGeom prst="rect">
+            <a:avLst/>
+          </a:prstGeom>
+          <a:noFill/>
+        </p:spPr>
+        <p:txBody>
+          <a:bodyPr wrap="square" lIns="0" rIns="0" tIns="0" bIns="0" anchor="ctr">
+            <a:spAutoFit/>
+          </a:bodyPr>
+          <a:lstStyle/>
+          <a:p>
+            <a:pPr algn="l"/>
+            <a:r>
+              <a:rPr sz="1274" b="0" i="0">
+                <a:solidFill>
+                  <a:srgbClr val="0F172A"/>
+                </a:solidFill>
+                <a:latin typeface="Lato"/>
+              </a:rPr>
+              <a:t>Les risques qui causent réellement vos accidents sont identifiés et priorisés</a:t>
+            </a:r>
+          </a:p>
+        </p:txBody>
+      </p:sp>
+      <p:sp>
+        <p:nvSpPr>
+          <p:cNvPr id="6" name="TextBox 5"/>
+          <p:cNvSpPr txBox="1"/>
+          <p:nvPr/>
+        </p:nvSpPr>
+        <p:spPr>
+          <a:xfrm>
+            <a:off x="1352516" y="3793682"/>
+            <a:ext cx="4063947" cy="442901"/>
+          </a:xfrm>
+          <a:prstGeom prst="rect">
+            <a:avLst/>
+          </a:prstGeom>
+          <a:noFill/>
+        </p:spPr>
+        <p:txBody>
+          <a:bodyPr wrap="square" lIns="0" rIns="0" tIns="0" bIns="0" anchor="ctr">
+            <a:spAutoFit/>
+          </a:bodyPr>
+          <a:lstStyle/>
+          <a:p>
+            <a:pPr algn="l"/>
+            <a:r>
+              <a:rPr sz="1274" b="0" i="0">
+                <a:solidFill>
+                  <a:srgbClr val="0F172A"/>
+                </a:solidFill>
+                <a:latin typeface="Lato"/>
+              </a:rPr>
+              <a:t>Un lien possible avec vos données AT/MP via l'écosystème Acciline+, en option</a:t>
+            </a:r>
+          </a:p>
+        </p:txBody>
+      </p:sp>
+      <p:sp>
+        <p:nvSpPr>
+          <p:cNvPr id="7" name="TextBox 6"/>
+          <p:cNvSpPr txBox="1"/>
+          <p:nvPr/>
+        </p:nvSpPr>
+        <p:spPr>
+          <a:xfrm>
+            <a:off x="1352516" y="4469940"/>
+            <a:ext cx="4450147" cy="200019"/>
+          </a:xfrm>
+          <a:prstGeom prst="rect">
+            <a:avLst/>
+          </a:prstGeom>
+          <a:noFill/>
+        </p:spPr>
+        <p:txBody>
+          <a:bodyPr wrap="square" lIns="0" rIns="0" tIns="0" bIns="0" anchor="ctr">
+            <a:spAutoFit/>
+          </a:bodyPr>
+          <a:lstStyle/>
+          <a:p>
+            <a:pPr algn="l"/>
+            <a:r>
+              <a:rPr sz="1274" b="0" i="0">
+                <a:solidFill>
+                  <a:srgbClr val="0F172A"/>
+                </a:solidFill>
+                <a:latin typeface="Lato"/>
+              </a:rPr>
+              <a:t>Une vue consolidée multi-sites pour homogénéiser la démarche</a:t>
+            </a:r>
+          </a:p>
+        </p:txBody>
+      </p:sp>
     </p:spTree>
   </p:cSld>
   <p:clrMapOvr>
@@ -3901,6 +7067,181 @@
           </a:prstGeom>
         </p:spPr>
       </p:pic>
+      <p:sp>
+        <p:nvSpPr>
+          <p:cNvPr id="3" name="TextBox 2"/>
+          <p:cNvSpPr txBox="1"/>
+          <p:nvPr/>
+        </p:nvSpPr>
+        <p:spPr>
+          <a:xfrm>
+            <a:off x="952476" y="1584979"/>
+            <a:ext cx="4312931" cy="872408"/>
+          </a:xfrm>
+          <a:prstGeom prst="rect">
+            <a:avLst/>
+          </a:prstGeom>
+          <a:noFill/>
+        </p:spPr>
+        <p:txBody>
+          <a:bodyPr wrap="square" lIns="0" rIns="0" tIns="0" bIns="0" anchor="ctr">
+            <a:spAutoFit/>
+          </a:bodyPr>
+          <a:lstStyle/>
+          <a:p>
+            <a:pPr algn="l"/>
+            <a:r>
+              <a:rPr sz="2849" b="1" i="0">
+                <a:solidFill>
+                  <a:srgbClr val="0F172A"/>
+                </a:solidFill>
+                <a:latin typeface="Lato"/>
+              </a:rPr>
+              <a:t>Un plan d'action piloté, pas une liste oubliée</a:t>
+            </a:r>
+          </a:p>
+        </p:txBody>
+      </p:sp>
+      <p:sp>
+        <p:nvSpPr>
+          <p:cNvPr id="4" name="TextBox 3"/>
+          <p:cNvSpPr txBox="1"/>
+          <p:nvPr/>
+        </p:nvSpPr>
+        <p:spPr>
+          <a:xfrm>
+            <a:off x="1352516" y="2767836"/>
+            <a:ext cx="4036117" cy="200019"/>
+          </a:xfrm>
+          <a:prstGeom prst="rect">
+            <a:avLst/>
+          </a:prstGeom>
+          <a:noFill/>
+        </p:spPr>
+        <p:txBody>
+          <a:bodyPr wrap="square" lIns="0" rIns="0" tIns="0" bIns="0" anchor="ctr">
+            <a:spAutoFit/>
+          </a:bodyPr>
+          <a:lstStyle/>
+          <a:p>
+            <a:pPr algn="l"/>
+            <a:r>
+              <a:rPr sz="1274" b="0" i="0">
+                <a:solidFill>
+                  <a:srgbClr val="0F172A"/>
+                </a:solidFill>
+                <a:latin typeface="Lato"/>
+              </a:rPr>
+              <a:t>Programme d'actions priorisé selon la criticité des risques</a:t>
+            </a:r>
+          </a:p>
+        </p:txBody>
+      </p:sp>
+      <p:sp>
+        <p:nvSpPr>
+          <p:cNvPr id="5" name="TextBox 4"/>
+          <p:cNvSpPr txBox="1"/>
+          <p:nvPr/>
+        </p:nvSpPr>
+        <p:spPr>
+          <a:xfrm>
+            <a:off x="1352516" y="3225024"/>
+            <a:ext cx="4183751" cy="442901"/>
+          </a:xfrm>
+          <a:prstGeom prst="rect">
+            <a:avLst/>
+          </a:prstGeom>
+          <a:noFill/>
+        </p:spPr>
+        <p:txBody>
+          <a:bodyPr wrap="square" lIns="0" rIns="0" tIns="0" bIns="0" anchor="ctr">
+            <a:spAutoFit/>
+          </a:bodyPr>
+          <a:lstStyle/>
+          <a:p>
+            <a:pPr algn="l"/>
+            <a:r>
+              <a:rPr sz="1274" b="0" i="0">
+                <a:solidFill>
+                  <a:srgbClr val="0F172A"/>
+                </a:solidFill>
+                <a:latin typeface="Lato"/>
+              </a:rPr>
+              <a:t>Suivi de l'exécution des actions dans le temps, par site et par responsable</a:t>
+            </a:r>
+          </a:p>
+        </p:txBody>
+      </p:sp>
+      <p:sp>
+        <p:nvSpPr>
+          <p:cNvPr id="6" name="TextBox 5"/>
+          <p:cNvSpPr txBox="1"/>
+          <p:nvPr/>
+        </p:nvSpPr>
+        <p:spPr>
+          <a:xfrm>
+            <a:off x="1352516" y="3901282"/>
+            <a:ext cx="3313724" cy="200019"/>
+          </a:xfrm>
+          <a:prstGeom prst="rect">
+            <a:avLst/>
+          </a:prstGeom>
+          <a:noFill/>
+        </p:spPr>
+        <p:txBody>
+          <a:bodyPr wrap="square" lIns="0" rIns="0" tIns="0" bIns="0" anchor="ctr">
+            <a:spAutoFit/>
+          </a:bodyPr>
+          <a:lstStyle/>
+          <a:p>
+            <a:pPr algn="l"/>
+            <a:r>
+              <a:rPr sz="1274" b="0" i="0">
+                <a:solidFill>
+                  <a:srgbClr val="0F172A"/>
+                </a:solidFill>
+                <a:latin typeface="Lato"/>
+              </a:rPr>
+              <a:t>Tableaux de bord de la démarche de prévention</a:t>
+            </a:r>
+          </a:p>
+        </p:txBody>
+      </p:sp>
+      <p:sp>
+        <p:nvSpPr>
+          <p:cNvPr id="7" name="TextBox 6"/>
+          <p:cNvSpPr txBox="1"/>
+          <p:nvPr/>
+        </p:nvSpPr>
+        <p:spPr>
+          <a:xfrm>
+            <a:off x="1352516" y="4358471"/>
+            <a:ext cx="4295072" cy="442901"/>
+          </a:xfrm>
+          <a:prstGeom prst="rect">
+            <a:avLst/>
+          </a:prstGeom>
+          <a:noFill/>
+        </p:spPr>
+        <p:txBody>
+          <a:bodyPr wrap="square" lIns="0" rIns="0" tIns="0" bIns="0" anchor="ctr">
+            <a:spAutoFit/>
+          </a:bodyPr>
+          <a:lstStyle/>
+          <a:p>
+            <a:pPr algn="l"/>
+            <a:r>
+              <a:rPr sz="1274" b="0" i="0">
+                <a:solidFill>
+                  <a:srgbClr val="0F172A"/>
+                </a:solidFill>
+                <a:latin typeface="Lato"/>
+              </a:rPr>
+              <a:t>Traçabilité complète pour vos échanges avec l'inspection et le SPST</a:t>
+            </a:r>
+          </a:p>
+        </p:txBody>
+      </p:sp>
     </p:spTree>
   </p:cSld>
   <p:clrMapOvr>

</xml_diff>